<commit_message>
Fix ROP diagrams, connector routing and report formatting
Apply practice 1-8 corrections, consolidate the Russian logical model, and use explicit BPMN merges and component ports. Separate independent routes and validate endpoints and false junctions. Update the report, editable models, exports and all eight presentation decks.

Validation: 12 native models, 34 SVG views, 105 report pages and 244 verified checksums.
</commit_message>
<xml_diff>
--- a/4/РОП/Практики_1-8/Презентации/РОП_Практическая_2_АлбахтинИВ.pptx
+++ b/4/РОП/Практики_1-8/Презентации/РОП_Практическая_2_АлбахтинИВ.pptx
@@ -2,22 +2,22 @@
 <file path=ppt/presentation.xml><?xml version="1.0" encoding="utf-8"?>
 <p:presentation xmlns:p="http://schemas.openxmlformats.org/presentationml/2006/main">
   <p:sldMasterIdLst>
-    <p:sldMasterId xmlns:r="http://schemas.openxmlformats.org/officeDocument/2006/relationships" id="2147483648" r:id="Rf36d6e36f22b488d"/>
+    <p:sldMasterId xmlns:r="http://schemas.openxmlformats.org/officeDocument/2006/relationships" id="2147483648" r:id="Re9c6a853f5264cbc"/>
   </p:sldMasterIdLst>
   <p:notesMasterIdLst>
-    <p:notesMasterId xmlns:r="http://schemas.openxmlformats.org/officeDocument/2006/relationships" r:id="R8560a40f4c274f94"/>
+    <p:notesMasterId xmlns:r="http://schemas.openxmlformats.org/officeDocument/2006/relationships" r:id="R62e1d5ed05884f96"/>
   </p:notesMasterIdLst>
   <p:sldIdLst>
-    <p:sldId xmlns:r="http://schemas.openxmlformats.org/officeDocument/2006/relationships" id="256" r:id="R695af3602dd14d92"/>
-    <p:sldId xmlns:r="http://schemas.openxmlformats.org/officeDocument/2006/relationships" id="257" r:id="R660f3bf21dad4c6b"/>
-    <p:sldId xmlns:r="http://schemas.openxmlformats.org/officeDocument/2006/relationships" id="258" r:id="R8657fd6bef734da3"/>
-    <p:sldId xmlns:r="http://schemas.openxmlformats.org/officeDocument/2006/relationships" id="259" r:id="R54f2c5e1cb19470a"/>
-    <p:sldId xmlns:r="http://schemas.openxmlformats.org/officeDocument/2006/relationships" id="260" r:id="R01426e8cdd0b4f63"/>
-    <p:sldId xmlns:r="http://schemas.openxmlformats.org/officeDocument/2006/relationships" id="261" r:id="R3a820b7c447c404f"/>
-    <p:sldId xmlns:r="http://schemas.openxmlformats.org/officeDocument/2006/relationships" id="262" r:id="Rb46309d4fc40414f"/>
-    <p:sldId xmlns:r="http://schemas.openxmlformats.org/officeDocument/2006/relationships" id="263" r:id="Rb54c44e178c343b3"/>
-    <p:sldId xmlns:r="http://schemas.openxmlformats.org/officeDocument/2006/relationships" id="264" r:id="R27046f9affff4bea"/>
-    <p:sldId xmlns:r="http://schemas.openxmlformats.org/officeDocument/2006/relationships" id="265" r:id="Rd905692064a1412c"/>
+    <p:sldId xmlns:r="http://schemas.openxmlformats.org/officeDocument/2006/relationships" id="256" r:id="Rfbec5f3c17504976"/>
+    <p:sldId xmlns:r="http://schemas.openxmlformats.org/officeDocument/2006/relationships" id="257" r:id="R80730229b8444a87"/>
+    <p:sldId xmlns:r="http://schemas.openxmlformats.org/officeDocument/2006/relationships" id="258" r:id="R90c25645aeb44e21"/>
+    <p:sldId xmlns:r="http://schemas.openxmlformats.org/officeDocument/2006/relationships" id="259" r:id="Raffa92c6f2104e3b"/>
+    <p:sldId xmlns:r="http://schemas.openxmlformats.org/officeDocument/2006/relationships" id="260" r:id="Rd5f3222b207a4084"/>
+    <p:sldId xmlns:r="http://schemas.openxmlformats.org/officeDocument/2006/relationships" id="261" r:id="R8b225176dc914f7e"/>
+    <p:sldId xmlns:r="http://schemas.openxmlformats.org/officeDocument/2006/relationships" id="262" r:id="R204305f24e9144ca"/>
+    <p:sldId xmlns:r="http://schemas.openxmlformats.org/officeDocument/2006/relationships" id="263" r:id="R00f9fd11d34146df"/>
+    <p:sldId xmlns:r="http://schemas.openxmlformats.org/officeDocument/2006/relationships" id="264" r:id="R3d33d014a22040cf"/>
+    <p:sldId xmlns:r="http://schemas.openxmlformats.org/officeDocument/2006/relationships" id="265" r:id="R95f82111c40449ec"/>
   </p:sldIdLst>
   <p:sldSz cx="12192000" cy="6858000"/>
   <p:notesSz cx="6858000" cy="9144000"/>
@@ -207,16 +207,16 @@
         <a:srgbClr val="96607D"/>
       </a:folHlink>
     </a:clrScheme>
-    <a:fontScheme name="Office">
+    <a:fontScheme name="">
       <a:majorFont>
-        <a:latin typeface="Calibri Light"/>
-        <a:ea typeface="Calibri Light"/>
-        <a:cs typeface="Calibri Light"/>
+        <a:latin typeface="Aptos"/>
+        <a:ea typeface=""/>
+        <a:cs typeface=""/>
       </a:majorFont>
       <a:minorFont>
-        <a:latin typeface="Calibri"/>
-        <a:ea typeface="Calibri"/>
-        <a:cs typeface="Calibri"/>
+        <a:latin typeface="Aptos"/>
+        <a:ea typeface=""/>
+        <a:cs typeface=""/>
       </a:minorFont>
     </a:fontScheme>
     <a:fmtScheme name="ChatGPT">
@@ -1173,6 +1173,1661 @@
       <p:grpSpPr>
         <a:xfrm xmlns:a="http://schemas.openxmlformats.org/drawingml/2006/main"/>
       </p:grpSpPr>
+      <p:sp>
+        <p:nvSpPr>
+          <p:cNvPr id="3" name="Title">
+            <a:extLst xmlns:a="http://schemas.openxmlformats.org/drawingml/2006/main">
+              <a:ext uri="{FF2B5EF4-FFF2-40B4-BE49-F238E27FC236}">
+                <a16:creationId xmlns:a16="http://schemas.microsoft.com/office/drawing/2014/main" id="{D7E45373-AD53-493A-B062-A9C85EF67BD0}"/>
+              </a:ext>
+            </a:extLst>
+          </p:cNvPr>
+          <p:cNvSpPr>
+            <a:spLocks xmlns:a="http://schemas.openxmlformats.org/drawingml/2006/main" noGrp="1"/>
+          </p:cNvSpPr>
+          <p:nvPr>
+            <p:ph type="title" idx="0"/>
+          </p:nvPr>
+        </p:nvSpPr>
+        <p:spPr>
+          <a:xfrm xmlns:a="http://schemas.openxmlformats.org/drawingml/2006/main">
+            <a:off x="1219200" y="2590800"/>
+            <a:ext cx="9753600" cy="990600"/>
+          </a:xfrm>
+          <a:prstGeom xmlns:a="http://schemas.openxmlformats.org/drawingml/2006/main" prst="rect">
+            <a:avLst/>
+          </a:prstGeom>
+          <a:noFill xmlns:a="http://schemas.openxmlformats.org/drawingml/2006/main"/>
+          <a:ln xmlns:a="http://schemas.openxmlformats.org/drawingml/2006/main">
+            <a:noFill/>
+            <a:prstDash val="solid"/>
+          </a:ln>
+        </p:spPr>
+        <p:txBody>
+          <a:bodyPr xmlns:a="http://schemas.openxmlformats.org/drawingml/2006/main" wrap="square" lIns="0" tIns="0" rIns="0" bIns="0" anchor="ctr">
+            <a:normAutofit/>
+          </a:bodyPr>
+          <a:lstStyle xmlns:a="http://schemas.openxmlformats.org/drawingml/2006/main">
+            <a:defPPr algn="ctr">
+              <a:defRPr sz="4800" b="1">
+                <a:solidFill>
+                  <a:schemeClr val="tx1"/>
+                </a:solidFill>
+                <a:latin typeface="+mj-lt"/>
+                <a:ea typeface="+mj-lt"/>
+                <a:cs typeface="+mj-lt"/>
+              </a:defRPr>
+            </a:defPPr>
+            <a:lvl1pPr marL="0" indent="0">
+              <a:lnSpc>
+                <a:spcPct val="110000"/>
+              </a:lnSpc>
+              <a:spcBef>
+                <a:spcPts val="0"/>
+              </a:spcBef>
+              <a:spcAft>
+                <a:spcPts val="0"/>
+              </a:spcAft>
+              <a:buNone/>
+            </a:lvl1pPr>
+            <a:lvl2pPr marL="0" indent="0">
+              <a:lnSpc>
+                <a:spcPct val="110000"/>
+              </a:lnSpc>
+              <a:spcBef>
+                <a:spcPts val="0"/>
+              </a:spcBef>
+              <a:spcAft>
+                <a:spcPts val="0"/>
+              </a:spcAft>
+              <a:buNone/>
+            </a:lvl2pPr>
+            <a:lvl3pPr marL="0" indent="0">
+              <a:lnSpc>
+                <a:spcPct val="110000"/>
+              </a:lnSpc>
+              <a:spcBef>
+                <a:spcPts val="0"/>
+              </a:spcBef>
+              <a:spcAft>
+                <a:spcPts val="0"/>
+              </a:spcAft>
+              <a:buNone/>
+            </a:lvl3pPr>
+            <a:lvl4pPr marL="0" indent="0">
+              <a:lnSpc>
+                <a:spcPct val="110000"/>
+              </a:lnSpc>
+              <a:spcBef>
+                <a:spcPts val="0"/>
+              </a:spcBef>
+              <a:spcAft>
+                <a:spcPts val="0"/>
+              </a:spcAft>
+              <a:buNone/>
+            </a:lvl4pPr>
+            <a:lvl5pPr marL="0" indent="0">
+              <a:lnSpc>
+                <a:spcPct val="110000"/>
+              </a:lnSpc>
+              <a:spcBef>
+                <a:spcPts val="0"/>
+              </a:spcBef>
+              <a:spcAft>
+                <a:spcPts val="0"/>
+              </a:spcAft>
+              <a:buNone/>
+            </a:lvl5pPr>
+            <a:lvl6pPr marL="0" indent="0">
+              <a:lnSpc>
+                <a:spcPct val="110000"/>
+              </a:lnSpc>
+              <a:spcBef>
+                <a:spcPts val="0"/>
+              </a:spcBef>
+              <a:spcAft>
+                <a:spcPts val="0"/>
+              </a:spcAft>
+              <a:buNone/>
+            </a:lvl6pPr>
+            <a:lvl7pPr marL="0" indent="0">
+              <a:lnSpc>
+                <a:spcPct val="110000"/>
+              </a:lnSpc>
+              <a:spcBef>
+                <a:spcPts val="0"/>
+              </a:spcBef>
+              <a:spcAft>
+                <a:spcPts val="0"/>
+              </a:spcAft>
+              <a:buNone/>
+            </a:lvl7pPr>
+            <a:lvl8pPr marL="0" indent="0">
+              <a:lnSpc>
+                <a:spcPct val="110000"/>
+              </a:lnSpc>
+              <a:spcBef>
+                <a:spcPts val="0"/>
+              </a:spcBef>
+              <a:spcAft>
+                <a:spcPts val="0"/>
+              </a:spcAft>
+              <a:buNone/>
+            </a:lvl8pPr>
+            <a:lvl9pPr marL="0" indent="0">
+              <a:lnSpc>
+                <a:spcPct val="110000"/>
+              </a:lnSpc>
+              <a:spcBef>
+                <a:spcPts val="0"/>
+              </a:spcBef>
+              <a:spcAft>
+                <a:spcPts val="0"/>
+              </a:spcAft>
+              <a:buNone/>
+            </a:lvl9pPr>
+          </a:lstStyle>
+          <a:p xmlns:a="http://schemas.openxmlformats.org/drawingml/2006/main"/>
+        </p:txBody>
+      </p:sp>
+      <p:sp>
+        <p:nvSpPr>
+          <p:cNvPr id="2" name="Subtitle">
+            <a:extLst xmlns:a="http://schemas.openxmlformats.org/drawingml/2006/main">
+              <a:ext uri="{FF2B5EF4-FFF2-40B4-BE49-F238E27FC236}">
+                <a16:creationId xmlns:a16="http://schemas.microsoft.com/office/drawing/2014/main" id="{EA8861AC-99B2-410E-8D6B-A9FFACF0DD0B}"/>
+              </a:ext>
+            </a:extLst>
+          </p:cNvPr>
+          <p:cNvSpPr>
+            <a:spLocks xmlns:a="http://schemas.openxmlformats.org/drawingml/2006/main" noGrp="1"/>
+          </p:cNvSpPr>
+          <p:nvPr>
+            <p:ph type="subTitle" idx="1"/>
+          </p:nvPr>
+        </p:nvSpPr>
+        <p:spPr>
+          <a:xfrm xmlns:a="http://schemas.openxmlformats.org/drawingml/2006/main">
+            <a:off x="1828800" y="3771900"/>
+            <a:ext cx="8534400" cy="762000"/>
+          </a:xfrm>
+          <a:prstGeom xmlns:a="http://schemas.openxmlformats.org/drawingml/2006/main" prst="rect">
+            <a:avLst/>
+          </a:prstGeom>
+          <a:noFill xmlns:a="http://schemas.openxmlformats.org/drawingml/2006/main"/>
+          <a:ln xmlns:a="http://schemas.openxmlformats.org/drawingml/2006/main">
+            <a:noFill/>
+            <a:prstDash val="solid"/>
+          </a:ln>
+        </p:spPr>
+        <p:txBody>
+          <a:bodyPr xmlns:a="http://schemas.openxmlformats.org/drawingml/2006/main" wrap="square" lIns="0" tIns="0" rIns="0" bIns="0" anchor="ctr">
+            <a:normAutofit/>
+          </a:bodyPr>
+          <a:lstStyle xmlns:a="http://schemas.openxmlformats.org/drawingml/2006/main">
+            <a:defPPr algn="ctr">
+              <a:defRPr sz="2100" b="0">
+                <a:solidFill>
+                  <a:schemeClr val="tx1"/>
+                </a:solidFill>
+                <a:latin typeface="+mn-lt"/>
+                <a:ea typeface="+mn-lt"/>
+                <a:cs typeface="+mn-lt"/>
+              </a:defRPr>
+            </a:defPPr>
+            <a:lvl1pPr marL="0" indent="0">
+              <a:lnSpc>
+                <a:spcPct val="110000"/>
+              </a:lnSpc>
+              <a:spcBef>
+                <a:spcPts val="0"/>
+              </a:spcBef>
+              <a:spcAft>
+                <a:spcPts val="0"/>
+              </a:spcAft>
+              <a:buNone/>
+            </a:lvl1pPr>
+            <a:lvl2pPr marL="0" indent="0">
+              <a:lnSpc>
+                <a:spcPct val="110000"/>
+              </a:lnSpc>
+              <a:spcBef>
+                <a:spcPts val="0"/>
+              </a:spcBef>
+              <a:spcAft>
+                <a:spcPts val="0"/>
+              </a:spcAft>
+              <a:buNone/>
+            </a:lvl2pPr>
+            <a:lvl3pPr marL="0" indent="0">
+              <a:lnSpc>
+                <a:spcPct val="110000"/>
+              </a:lnSpc>
+              <a:spcBef>
+                <a:spcPts val="0"/>
+              </a:spcBef>
+              <a:spcAft>
+                <a:spcPts val="0"/>
+              </a:spcAft>
+              <a:buNone/>
+            </a:lvl3pPr>
+            <a:lvl4pPr marL="0" indent="0">
+              <a:lnSpc>
+                <a:spcPct val="110000"/>
+              </a:lnSpc>
+              <a:spcBef>
+                <a:spcPts val="0"/>
+              </a:spcBef>
+              <a:spcAft>
+                <a:spcPts val="0"/>
+              </a:spcAft>
+              <a:buNone/>
+            </a:lvl4pPr>
+            <a:lvl5pPr marL="0" indent="0">
+              <a:lnSpc>
+                <a:spcPct val="110000"/>
+              </a:lnSpc>
+              <a:spcBef>
+                <a:spcPts val="0"/>
+              </a:spcBef>
+              <a:spcAft>
+                <a:spcPts val="0"/>
+              </a:spcAft>
+              <a:buNone/>
+            </a:lvl5pPr>
+            <a:lvl6pPr marL="0" indent="0">
+              <a:lnSpc>
+                <a:spcPct val="110000"/>
+              </a:lnSpc>
+              <a:spcBef>
+                <a:spcPts val="0"/>
+              </a:spcBef>
+              <a:spcAft>
+                <a:spcPts val="0"/>
+              </a:spcAft>
+              <a:buNone/>
+            </a:lvl6pPr>
+            <a:lvl7pPr marL="0" indent="0">
+              <a:lnSpc>
+                <a:spcPct val="110000"/>
+              </a:lnSpc>
+              <a:spcBef>
+                <a:spcPts val="0"/>
+              </a:spcBef>
+              <a:spcAft>
+                <a:spcPts val="0"/>
+              </a:spcAft>
+              <a:buNone/>
+            </a:lvl7pPr>
+            <a:lvl8pPr marL="0" indent="0">
+              <a:lnSpc>
+                <a:spcPct val="110000"/>
+              </a:lnSpc>
+              <a:spcBef>
+                <a:spcPts val="0"/>
+              </a:spcBef>
+              <a:spcAft>
+                <a:spcPts val="0"/>
+              </a:spcAft>
+              <a:buNone/>
+            </a:lvl8pPr>
+            <a:lvl9pPr marL="0" indent="0">
+              <a:lnSpc>
+                <a:spcPct val="110000"/>
+              </a:lnSpc>
+              <a:spcBef>
+                <a:spcPts val="0"/>
+              </a:spcBef>
+              <a:spcAft>
+                <a:spcPts val="0"/>
+              </a:spcAft>
+              <a:buNone/>
+            </a:lvl9pPr>
+          </a:lstStyle>
+          <a:p xmlns:a="http://schemas.openxmlformats.org/drawingml/2006/main"/>
+        </p:txBody>
+      </p:sp>
+    </p:spTree>
+  </p:cSld>
+</p:sldLayout>
+</file>
+
+<file path=ppt/slideLayouts/slideLayout2.xml><?xml version="1.0" encoding="utf-8"?>
+<p:sldLayout xmlns:p="http://schemas.openxmlformats.org/presentationml/2006/main">
+  <p:cSld name="Section Header">
+    <p:spTree>
+      <p:nvGrpSpPr>
+        <p:cNvPr id="1" name=""/>
+        <p:cNvGrpSpPr/>
+        <p:nvPr/>
+      </p:nvGrpSpPr>
+      <p:grpSpPr>
+        <a:xfrm xmlns:a="http://schemas.openxmlformats.org/drawingml/2006/main"/>
+      </p:grpSpPr>
+      <p:sp>
+        <p:nvSpPr>
+          <p:cNvPr id="2" name="Section title">
+            <a:extLst xmlns:a="http://schemas.openxmlformats.org/drawingml/2006/main">
+              <a:ext uri="{FF2B5EF4-FFF2-40B4-BE49-F238E27FC236}">
+                <a16:creationId xmlns:a16="http://schemas.microsoft.com/office/drawing/2014/main" id="{DBAB1004-0ACA-4009-B660-C983BF880D4C}"/>
+              </a:ext>
+            </a:extLst>
+          </p:cNvPr>
+          <p:cNvSpPr>
+            <a:spLocks xmlns:a="http://schemas.openxmlformats.org/drawingml/2006/main" noGrp="1"/>
+          </p:cNvSpPr>
+          <p:nvPr>
+            <p:ph type="title" idx="0"/>
+          </p:nvPr>
+        </p:nvSpPr>
+        <p:spPr>
+          <a:xfrm xmlns:a="http://schemas.openxmlformats.org/drawingml/2006/main">
+            <a:off x="1219200" y="2857500"/>
+            <a:ext cx="9753600" cy="1143000"/>
+          </a:xfrm>
+          <a:prstGeom xmlns:a="http://schemas.openxmlformats.org/drawingml/2006/main" prst="rect">
+            <a:avLst/>
+          </a:prstGeom>
+          <a:noFill xmlns:a="http://schemas.openxmlformats.org/drawingml/2006/main"/>
+          <a:ln xmlns:a="http://schemas.openxmlformats.org/drawingml/2006/main">
+            <a:noFill/>
+            <a:prstDash val="solid"/>
+          </a:ln>
+        </p:spPr>
+        <p:txBody>
+          <a:bodyPr xmlns:a="http://schemas.openxmlformats.org/drawingml/2006/main" wrap="square" lIns="0" tIns="0" rIns="0" bIns="0" anchor="ctr">
+            <a:normAutofit/>
+          </a:bodyPr>
+          <a:lstStyle xmlns:a="http://schemas.openxmlformats.org/drawingml/2006/main">
+            <a:defPPr algn="ctr">
+              <a:defRPr sz="4200" b="1">
+                <a:solidFill>
+                  <a:schemeClr val="tx1"/>
+                </a:solidFill>
+                <a:latin typeface="+mj-lt"/>
+                <a:ea typeface="+mj-lt"/>
+                <a:cs typeface="+mj-lt"/>
+              </a:defRPr>
+            </a:defPPr>
+            <a:lvl1pPr marL="0" indent="0">
+              <a:lnSpc>
+                <a:spcPct val="110000"/>
+              </a:lnSpc>
+              <a:spcBef>
+                <a:spcPts val="0"/>
+              </a:spcBef>
+              <a:spcAft>
+                <a:spcPts val="0"/>
+              </a:spcAft>
+              <a:buNone/>
+            </a:lvl1pPr>
+            <a:lvl2pPr marL="0" indent="0">
+              <a:lnSpc>
+                <a:spcPct val="110000"/>
+              </a:lnSpc>
+              <a:spcBef>
+                <a:spcPts val="0"/>
+              </a:spcBef>
+              <a:spcAft>
+                <a:spcPts val="0"/>
+              </a:spcAft>
+              <a:buNone/>
+            </a:lvl2pPr>
+            <a:lvl3pPr marL="0" indent="0">
+              <a:lnSpc>
+                <a:spcPct val="110000"/>
+              </a:lnSpc>
+              <a:spcBef>
+                <a:spcPts val="0"/>
+              </a:spcBef>
+              <a:spcAft>
+                <a:spcPts val="0"/>
+              </a:spcAft>
+              <a:buNone/>
+            </a:lvl3pPr>
+            <a:lvl4pPr marL="0" indent="0">
+              <a:lnSpc>
+                <a:spcPct val="110000"/>
+              </a:lnSpc>
+              <a:spcBef>
+                <a:spcPts val="0"/>
+              </a:spcBef>
+              <a:spcAft>
+                <a:spcPts val="0"/>
+              </a:spcAft>
+              <a:buNone/>
+            </a:lvl4pPr>
+            <a:lvl5pPr marL="0" indent="0">
+              <a:lnSpc>
+                <a:spcPct val="110000"/>
+              </a:lnSpc>
+              <a:spcBef>
+                <a:spcPts val="0"/>
+              </a:spcBef>
+              <a:spcAft>
+                <a:spcPts val="0"/>
+              </a:spcAft>
+              <a:buNone/>
+            </a:lvl5pPr>
+            <a:lvl6pPr marL="0" indent="0">
+              <a:lnSpc>
+                <a:spcPct val="110000"/>
+              </a:lnSpc>
+              <a:spcBef>
+                <a:spcPts val="0"/>
+              </a:spcBef>
+              <a:spcAft>
+                <a:spcPts val="0"/>
+              </a:spcAft>
+              <a:buNone/>
+            </a:lvl6pPr>
+            <a:lvl7pPr marL="0" indent="0">
+              <a:lnSpc>
+                <a:spcPct val="110000"/>
+              </a:lnSpc>
+              <a:spcBef>
+                <a:spcPts val="0"/>
+              </a:spcBef>
+              <a:spcAft>
+                <a:spcPts val="0"/>
+              </a:spcAft>
+              <a:buNone/>
+            </a:lvl7pPr>
+            <a:lvl8pPr marL="0" indent="0">
+              <a:lnSpc>
+                <a:spcPct val="110000"/>
+              </a:lnSpc>
+              <a:spcBef>
+                <a:spcPts val="0"/>
+              </a:spcBef>
+              <a:spcAft>
+                <a:spcPts val="0"/>
+              </a:spcAft>
+              <a:buNone/>
+            </a:lvl8pPr>
+            <a:lvl9pPr marL="0" indent="0">
+              <a:lnSpc>
+                <a:spcPct val="110000"/>
+              </a:lnSpc>
+              <a:spcBef>
+                <a:spcPts val="0"/>
+              </a:spcBef>
+              <a:spcAft>
+                <a:spcPts val="0"/>
+              </a:spcAft>
+              <a:buNone/>
+            </a:lvl9pPr>
+          </a:lstStyle>
+          <a:p xmlns:a="http://schemas.openxmlformats.org/drawingml/2006/main"/>
+        </p:txBody>
+      </p:sp>
+    </p:spTree>
+  </p:cSld>
+</p:sldLayout>
+</file>
+
+<file path=ppt/slideLayouts/slideLayout3.xml><?xml version="1.0" encoding="utf-8"?>
+<p:sldLayout xmlns:p="http://schemas.openxmlformats.org/presentationml/2006/main">
+  <p:cSld name="Title and Body">
+    <p:spTree>
+      <p:nvGrpSpPr>
+        <p:cNvPr id="1" name=""/>
+        <p:cNvGrpSpPr/>
+        <p:nvPr/>
+      </p:nvGrpSpPr>
+      <p:grpSpPr>
+        <a:xfrm xmlns:a="http://schemas.openxmlformats.org/drawingml/2006/main"/>
+      </p:grpSpPr>
+      <p:sp>
+        <p:nvSpPr>
+          <p:cNvPr id="3" name="Title">
+            <a:extLst xmlns:a="http://schemas.openxmlformats.org/drawingml/2006/main">
+              <a:ext uri="{FF2B5EF4-FFF2-40B4-BE49-F238E27FC236}">
+                <a16:creationId xmlns:a16="http://schemas.microsoft.com/office/drawing/2014/main" id="{D9167736-1E5E-4867-8E9E-323A8103E688}"/>
+              </a:ext>
+            </a:extLst>
+          </p:cNvPr>
+          <p:cNvSpPr>
+            <a:spLocks xmlns:a="http://schemas.openxmlformats.org/drawingml/2006/main" noGrp="1"/>
+          </p:cNvSpPr>
+          <p:nvPr>
+            <p:ph type="title" idx="0"/>
+          </p:nvPr>
+        </p:nvSpPr>
+        <p:spPr>
+          <a:xfrm xmlns:a="http://schemas.openxmlformats.org/drawingml/2006/main">
+            <a:off x="685800" y="533400"/>
+            <a:ext cx="10820400" cy="838200"/>
+          </a:xfrm>
+          <a:prstGeom xmlns:a="http://schemas.openxmlformats.org/drawingml/2006/main" prst="rect">
+            <a:avLst/>
+          </a:prstGeom>
+          <a:noFill xmlns:a="http://schemas.openxmlformats.org/drawingml/2006/main"/>
+          <a:ln xmlns:a="http://schemas.openxmlformats.org/drawingml/2006/main">
+            <a:noFill/>
+            <a:prstDash val="solid"/>
+          </a:ln>
+        </p:spPr>
+        <p:txBody>
+          <a:bodyPr xmlns:a="http://schemas.openxmlformats.org/drawingml/2006/main" wrap="square" lIns="0" tIns="0" rIns="0" bIns="0" anchor="t">
+            <a:normAutofit/>
+          </a:bodyPr>
+          <a:lstStyle xmlns:a="http://schemas.openxmlformats.org/drawingml/2006/main">
+            <a:defPPr algn="l">
+              <a:defRPr sz="3300" b="1">
+                <a:solidFill>
+                  <a:schemeClr val="tx1"/>
+                </a:solidFill>
+                <a:latin typeface="+mj-lt"/>
+                <a:ea typeface="+mj-lt"/>
+                <a:cs typeface="+mj-lt"/>
+              </a:defRPr>
+            </a:defPPr>
+            <a:lvl1pPr marL="0" indent="0">
+              <a:lnSpc>
+                <a:spcPct val="110000"/>
+              </a:lnSpc>
+              <a:spcBef>
+                <a:spcPts val="0"/>
+              </a:spcBef>
+              <a:spcAft>
+                <a:spcPts val="0"/>
+              </a:spcAft>
+              <a:buNone/>
+            </a:lvl1pPr>
+            <a:lvl2pPr marL="0" indent="0">
+              <a:lnSpc>
+                <a:spcPct val="110000"/>
+              </a:lnSpc>
+              <a:spcBef>
+                <a:spcPts val="0"/>
+              </a:spcBef>
+              <a:spcAft>
+                <a:spcPts val="0"/>
+              </a:spcAft>
+              <a:buNone/>
+            </a:lvl2pPr>
+            <a:lvl3pPr marL="0" indent="0">
+              <a:lnSpc>
+                <a:spcPct val="110000"/>
+              </a:lnSpc>
+              <a:spcBef>
+                <a:spcPts val="0"/>
+              </a:spcBef>
+              <a:spcAft>
+                <a:spcPts val="0"/>
+              </a:spcAft>
+              <a:buNone/>
+            </a:lvl3pPr>
+            <a:lvl4pPr marL="0" indent="0">
+              <a:lnSpc>
+                <a:spcPct val="110000"/>
+              </a:lnSpc>
+              <a:spcBef>
+                <a:spcPts val="0"/>
+              </a:spcBef>
+              <a:spcAft>
+                <a:spcPts val="0"/>
+              </a:spcAft>
+              <a:buNone/>
+            </a:lvl4pPr>
+            <a:lvl5pPr marL="0" indent="0">
+              <a:lnSpc>
+                <a:spcPct val="110000"/>
+              </a:lnSpc>
+              <a:spcBef>
+                <a:spcPts val="0"/>
+              </a:spcBef>
+              <a:spcAft>
+                <a:spcPts val="0"/>
+              </a:spcAft>
+              <a:buNone/>
+            </a:lvl5pPr>
+            <a:lvl6pPr marL="0" indent="0">
+              <a:lnSpc>
+                <a:spcPct val="110000"/>
+              </a:lnSpc>
+              <a:spcBef>
+                <a:spcPts val="0"/>
+              </a:spcBef>
+              <a:spcAft>
+                <a:spcPts val="0"/>
+              </a:spcAft>
+              <a:buNone/>
+            </a:lvl6pPr>
+            <a:lvl7pPr marL="0" indent="0">
+              <a:lnSpc>
+                <a:spcPct val="110000"/>
+              </a:lnSpc>
+              <a:spcBef>
+                <a:spcPts val="0"/>
+              </a:spcBef>
+              <a:spcAft>
+                <a:spcPts val="0"/>
+              </a:spcAft>
+              <a:buNone/>
+            </a:lvl7pPr>
+            <a:lvl8pPr marL="0" indent="0">
+              <a:lnSpc>
+                <a:spcPct val="110000"/>
+              </a:lnSpc>
+              <a:spcBef>
+                <a:spcPts val="0"/>
+              </a:spcBef>
+              <a:spcAft>
+                <a:spcPts val="0"/>
+              </a:spcAft>
+              <a:buNone/>
+            </a:lvl8pPr>
+            <a:lvl9pPr marL="0" indent="0">
+              <a:lnSpc>
+                <a:spcPct val="110000"/>
+              </a:lnSpc>
+              <a:spcBef>
+                <a:spcPts val="0"/>
+              </a:spcBef>
+              <a:spcAft>
+                <a:spcPts val="0"/>
+              </a:spcAft>
+              <a:buNone/>
+            </a:lvl9pPr>
+          </a:lstStyle>
+          <a:p xmlns:a="http://schemas.openxmlformats.org/drawingml/2006/main"/>
+        </p:txBody>
+      </p:sp>
+      <p:sp>
+        <p:nvSpPr>
+          <p:cNvPr id="2" name="Body">
+            <a:extLst xmlns:a="http://schemas.openxmlformats.org/drawingml/2006/main">
+              <a:ext uri="{FF2B5EF4-FFF2-40B4-BE49-F238E27FC236}">
+                <a16:creationId xmlns:a16="http://schemas.microsoft.com/office/drawing/2014/main" id="{F383D4D6-E3F1-4706-92D9-5A9A693DC906}"/>
+              </a:ext>
+            </a:extLst>
+          </p:cNvPr>
+          <p:cNvSpPr>
+            <a:spLocks xmlns:a="http://schemas.openxmlformats.org/drawingml/2006/main" noGrp="1"/>
+          </p:cNvSpPr>
+          <p:nvPr>
+            <p:ph type="body" idx="1"/>
+          </p:nvPr>
+        </p:nvSpPr>
+        <p:spPr>
+          <a:xfrm xmlns:a="http://schemas.openxmlformats.org/drawingml/2006/main">
+            <a:off x="685800" y="1905000"/>
+            <a:ext cx="10820400" cy="4267200"/>
+          </a:xfrm>
+          <a:prstGeom xmlns:a="http://schemas.openxmlformats.org/drawingml/2006/main" prst="rect">
+            <a:avLst/>
+          </a:prstGeom>
+          <a:noFill xmlns:a="http://schemas.openxmlformats.org/drawingml/2006/main"/>
+          <a:ln xmlns:a="http://schemas.openxmlformats.org/drawingml/2006/main">
+            <a:noFill/>
+            <a:prstDash val="solid"/>
+          </a:ln>
+        </p:spPr>
+        <p:txBody>
+          <a:bodyPr xmlns:a="http://schemas.openxmlformats.org/drawingml/2006/main" wrap="square" lIns="0" tIns="0" rIns="0" bIns="0" anchor="t">
+            <a:normAutofit/>
+          </a:bodyPr>
+          <a:lstStyle xmlns:a="http://schemas.openxmlformats.org/drawingml/2006/main">
+            <a:defPPr algn="l">
+              <a:defRPr sz="2250" b="0">
+                <a:solidFill>
+                  <a:schemeClr val="tx1"/>
+                </a:solidFill>
+                <a:latin typeface="+mn-lt"/>
+                <a:ea typeface="+mn-lt"/>
+                <a:cs typeface="+mn-lt"/>
+              </a:defRPr>
+            </a:defPPr>
+            <a:lvl1pPr marL="228600" indent="-228600">
+              <a:lnSpc>
+                <a:spcPct val="110000"/>
+              </a:lnSpc>
+              <a:spcBef>
+                <a:spcPts val="0"/>
+              </a:spcBef>
+              <a:spcAft>
+                <a:spcPts val="1200"/>
+              </a:spcAft>
+              <a:buChar char="•"/>
+            </a:lvl1pPr>
+            <a:lvl2pPr marL="533400" indent="-228600">
+              <a:lnSpc>
+                <a:spcPct val="110000"/>
+              </a:lnSpc>
+              <a:spcBef>
+                <a:spcPts val="0"/>
+              </a:spcBef>
+              <a:spcAft>
+                <a:spcPts val="1200"/>
+              </a:spcAft>
+              <a:buChar char="•"/>
+            </a:lvl2pPr>
+            <a:lvl3pPr marL="838200" indent="-228600">
+              <a:lnSpc>
+                <a:spcPct val="110000"/>
+              </a:lnSpc>
+              <a:spcBef>
+                <a:spcPts val="0"/>
+              </a:spcBef>
+              <a:spcAft>
+                <a:spcPts val="1200"/>
+              </a:spcAft>
+              <a:buChar char="•"/>
+            </a:lvl3pPr>
+            <a:lvl4pPr marL="1143000" indent="-228600">
+              <a:lnSpc>
+                <a:spcPct val="110000"/>
+              </a:lnSpc>
+              <a:spcBef>
+                <a:spcPts val="0"/>
+              </a:spcBef>
+              <a:spcAft>
+                <a:spcPts val="1200"/>
+              </a:spcAft>
+              <a:buChar char="•"/>
+            </a:lvl4pPr>
+            <a:lvl5pPr marL="1447800" indent="-228600">
+              <a:lnSpc>
+                <a:spcPct val="110000"/>
+              </a:lnSpc>
+              <a:spcBef>
+                <a:spcPts val="0"/>
+              </a:spcBef>
+              <a:spcAft>
+                <a:spcPts val="1200"/>
+              </a:spcAft>
+              <a:buChar char="•"/>
+            </a:lvl5pPr>
+            <a:lvl6pPr marL="1752600" indent="-228600">
+              <a:lnSpc>
+                <a:spcPct val="110000"/>
+              </a:lnSpc>
+              <a:spcBef>
+                <a:spcPts val="0"/>
+              </a:spcBef>
+              <a:spcAft>
+                <a:spcPts val="1200"/>
+              </a:spcAft>
+              <a:buChar char="•"/>
+            </a:lvl6pPr>
+            <a:lvl7pPr marL="2057400" indent="-228600">
+              <a:lnSpc>
+                <a:spcPct val="110000"/>
+              </a:lnSpc>
+              <a:spcBef>
+                <a:spcPts val="0"/>
+              </a:spcBef>
+              <a:spcAft>
+                <a:spcPts val="1200"/>
+              </a:spcAft>
+              <a:buChar char="•"/>
+            </a:lvl7pPr>
+            <a:lvl8pPr marL="2362200" indent="-228600">
+              <a:lnSpc>
+                <a:spcPct val="110000"/>
+              </a:lnSpc>
+              <a:spcBef>
+                <a:spcPts val="0"/>
+              </a:spcBef>
+              <a:spcAft>
+                <a:spcPts val="1200"/>
+              </a:spcAft>
+              <a:buChar char="•"/>
+            </a:lvl8pPr>
+            <a:lvl9pPr marL="2667000" indent="-228600">
+              <a:lnSpc>
+                <a:spcPct val="110000"/>
+              </a:lnSpc>
+              <a:spcBef>
+                <a:spcPts val="0"/>
+              </a:spcBef>
+              <a:spcAft>
+                <a:spcPts val="1200"/>
+              </a:spcAft>
+              <a:buChar char="•"/>
+            </a:lvl9pPr>
+          </a:lstStyle>
+          <a:p xmlns:a="http://schemas.openxmlformats.org/drawingml/2006/main"/>
+        </p:txBody>
+      </p:sp>
+    </p:spTree>
+  </p:cSld>
+</p:sldLayout>
+</file>
+
+<file path=ppt/slideLayouts/slideLayout4.xml><?xml version="1.0" encoding="utf-8"?>
+<p:sldLayout xmlns:p="http://schemas.openxmlformats.org/presentationml/2006/main">
+  <p:cSld name="Title and Two Column">
+    <p:spTree>
+      <p:nvGrpSpPr>
+        <p:cNvPr id="1" name=""/>
+        <p:cNvGrpSpPr/>
+        <p:nvPr/>
+      </p:nvGrpSpPr>
+      <p:grpSpPr>
+        <a:xfrm xmlns:a="http://schemas.openxmlformats.org/drawingml/2006/main"/>
+      </p:grpSpPr>
+      <p:sp>
+        <p:nvSpPr>
+          <p:cNvPr id="4" name="Title">
+            <a:extLst xmlns:a="http://schemas.openxmlformats.org/drawingml/2006/main">
+              <a:ext uri="{FF2B5EF4-FFF2-40B4-BE49-F238E27FC236}">
+                <a16:creationId xmlns:a16="http://schemas.microsoft.com/office/drawing/2014/main" id="{3F8C81B0-C4D6-498F-96F7-43987A5E61C8}"/>
+              </a:ext>
+            </a:extLst>
+          </p:cNvPr>
+          <p:cNvSpPr>
+            <a:spLocks xmlns:a="http://schemas.openxmlformats.org/drawingml/2006/main" noGrp="1"/>
+          </p:cNvSpPr>
+          <p:nvPr>
+            <p:ph type="title" idx="0"/>
+          </p:nvPr>
+        </p:nvSpPr>
+        <p:spPr>
+          <a:xfrm xmlns:a="http://schemas.openxmlformats.org/drawingml/2006/main">
+            <a:off x="685800" y="533400"/>
+            <a:ext cx="10820400" cy="838200"/>
+          </a:xfrm>
+          <a:prstGeom xmlns:a="http://schemas.openxmlformats.org/drawingml/2006/main" prst="rect">
+            <a:avLst/>
+          </a:prstGeom>
+          <a:noFill xmlns:a="http://schemas.openxmlformats.org/drawingml/2006/main"/>
+          <a:ln xmlns:a="http://schemas.openxmlformats.org/drawingml/2006/main">
+            <a:noFill/>
+            <a:prstDash val="solid"/>
+          </a:ln>
+        </p:spPr>
+        <p:txBody>
+          <a:bodyPr xmlns:a="http://schemas.openxmlformats.org/drawingml/2006/main" wrap="square" lIns="0" tIns="0" rIns="0" bIns="0" anchor="t">
+            <a:normAutofit/>
+          </a:bodyPr>
+          <a:lstStyle xmlns:a="http://schemas.openxmlformats.org/drawingml/2006/main">
+            <a:defPPr algn="l">
+              <a:defRPr sz="3300" b="1">
+                <a:solidFill>
+                  <a:schemeClr val="tx1"/>
+                </a:solidFill>
+                <a:latin typeface="+mj-lt"/>
+                <a:ea typeface="+mj-lt"/>
+                <a:cs typeface="+mj-lt"/>
+              </a:defRPr>
+            </a:defPPr>
+            <a:lvl1pPr marL="0" indent="0">
+              <a:lnSpc>
+                <a:spcPct val="110000"/>
+              </a:lnSpc>
+              <a:spcBef>
+                <a:spcPts val="0"/>
+              </a:spcBef>
+              <a:spcAft>
+                <a:spcPts val="0"/>
+              </a:spcAft>
+              <a:buNone/>
+            </a:lvl1pPr>
+            <a:lvl2pPr marL="0" indent="0">
+              <a:lnSpc>
+                <a:spcPct val="110000"/>
+              </a:lnSpc>
+              <a:spcBef>
+                <a:spcPts val="0"/>
+              </a:spcBef>
+              <a:spcAft>
+                <a:spcPts val="0"/>
+              </a:spcAft>
+              <a:buNone/>
+            </a:lvl2pPr>
+            <a:lvl3pPr marL="0" indent="0">
+              <a:lnSpc>
+                <a:spcPct val="110000"/>
+              </a:lnSpc>
+              <a:spcBef>
+                <a:spcPts val="0"/>
+              </a:spcBef>
+              <a:spcAft>
+                <a:spcPts val="0"/>
+              </a:spcAft>
+              <a:buNone/>
+            </a:lvl3pPr>
+            <a:lvl4pPr marL="0" indent="0">
+              <a:lnSpc>
+                <a:spcPct val="110000"/>
+              </a:lnSpc>
+              <a:spcBef>
+                <a:spcPts val="0"/>
+              </a:spcBef>
+              <a:spcAft>
+                <a:spcPts val="0"/>
+              </a:spcAft>
+              <a:buNone/>
+            </a:lvl4pPr>
+            <a:lvl5pPr marL="0" indent="0">
+              <a:lnSpc>
+                <a:spcPct val="110000"/>
+              </a:lnSpc>
+              <a:spcBef>
+                <a:spcPts val="0"/>
+              </a:spcBef>
+              <a:spcAft>
+                <a:spcPts val="0"/>
+              </a:spcAft>
+              <a:buNone/>
+            </a:lvl5pPr>
+            <a:lvl6pPr marL="0" indent="0">
+              <a:lnSpc>
+                <a:spcPct val="110000"/>
+              </a:lnSpc>
+              <a:spcBef>
+                <a:spcPts val="0"/>
+              </a:spcBef>
+              <a:spcAft>
+                <a:spcPts val="0"/>
+              </a:spcAft>
+              <a:buNone/>
+            </a:lvl6pPr>
+            <a:lvl7pPr marL="0" indent="0">
+              <a:lnSpc>
+                <a:spcPct val="110000"/>
+              </a:lnSpc>
+              <a:spcBef>
+                <a:spcPts val="0"/>
+              </a:spcBef>
+              <a:spcAft>
+                <a:spcPts val="0"/>
+              </a:spcAft>
+              <a:buNone/>
+            </a:lvl7pPr>
+            <a:lvl8pPr marL="0" indent="0">
+              <a:lnSpc>
+                <a:spcPct val="110000"/>
+              </a:lnSpc>
+              <a:spcBef>
+                <a:spcPts val="0"/>
+              </a:spcBef>
+              <a:spcAft>
+                <a:spcPts val="0"/>
+              </a:spcAft>
+              <a:buNone/>
+            </a:lvl8pPr>
+            <a:lvl9pPr marL="0" indent="0">
+              <a:lnSpc>
+                <a:spcPct val="110000"/>
+              </a:lnSpc>
+              <a:spcBef>
+                <a:spcPts val="0"/>
+              </a:spcBef>
+              <a:spcAft>
+                <a:spcPts val="0"/>
+              </a:spcAft>
+              <a:buNone/>
+            </a:lvl9pPr>
+          </a:lstStyle>
+          <a:p xmlns:a="http://schemas.openxmlformats.org/drawingml/2006/main"/>
+        </p:txBody>
+      </p:sp>
+      <p:sp>
+        <p:nvSpPr>
+          <p:cNvPr id="2" name="Left column">
+            <a:extLst xmlns:a="http://schemas.openxmlformats.org/drawingml/2006/main">
+              <a:ext uri="{FF2B5EF4-FFF2-40B4-BE49-F238E27FC236}">
+                <a16:creationId xmlns:a16="http://schemas.microsoft.com/office/drawing/2014/main" id="{199CF0FB-F07C-4560-8700-84A56D0098E1}"/>
+              </a:ext>
+            </a:extLst>
+          </p:cNvPr>
+          <p:cNvSpPr>
+            <a:spLocks xmlns:a="http://schemas.openxmlformats.org/drawingml/2006/main" noGrp="1"/>
+          </p:cNvSpPr>
+          <p:nvPr>
+            <p:ph type="body" idx="1"/>
+          </p:nvPr>
+        </p:nvSpPr>
+        <p:spPr>
+          <a:xfrm xmlns:a="http://schemas.openxmlformats.org/drawingml/2006/main">
+            <a:off x="685800" y="1905000"/>
+            <a:ext cx="5029200" cy="4267200"/>
+          </a:xfrm>
+          <a:prstGeom xmlns:a="http://schemas.openxmlformats.org/drawingml/2006/main" prst="rect">
+            <a:avLst/>
+          </a:prstGeom>
+          <a:noFill xmlns:a="http://schemas.openxmlformats.org/drawingml/2006/main"/>
+          <a:ln xmlns:a="http://schemas.openxmlformats.org/drawingml/2006/main">
+            <a:noFill/>
+            <a:prstDash val="solid"/>
+          </a:ln>
+        </p:spPr>
+        <p:txBody>
+          <a:bodyPr xmlns:a="http://schemas.openxmlformats.org/drawingml/2006/main" wrap="square" lIns="0" tIns="0" rIns="0" bIns="0" anchor="t">
+            <a:normAutofit/>
+          </a:bodyPr>
+          <a:lstStyle xmlns:a="http://schemas.openxmlformats.org/drawingml/2006/main">
+            <a:defPPr algn="l">
+              <a:defRPr sz="2100" b="0">
+                <a:solidFill>
+                  <a:schemeClr val="tx1"/>
+                </a:solidFill>
+                <a:latin typeface="+mn-lt"/>
+                <a:ea typeface="+mn-lt"/>
+                <a:cs typeface="+mn-lt"/>
+              </a:defRPr>
+            </a:defPPr>
+            <a:lvl1pPr marL="228600" indent="-228600">
+              <a:lnSpc>
+                <a:spcPct val="110000"/>
+              </a:lnSpc>
+              <a:spcBef>
+                <a:spcPts val="0"/>
+              </a:spcBef>
+              <a:spcAft>
+                <a:spcPts val="1200"/>
+              </a:spcAft>
+              <a:buChar char="•"/>
+            </a:lvl1pPr>
+            <a:lvl2pPr marL="533400" indent="-228600">
+              <a:lnSpc>
+                <a:spcPct val="110000"/>
+              </a:lnSpc>
+              <a:spcBef>
+                <a:spcPts val="0"/>
+              </a:spcBef>
+              <a:spcAft>
+                <a:spcPts val="1200"/>
+              </a:spcAft>
+              <a:buChar char="•"/>
+            </a:lvl2pPr>
+            <a:lvl3pPr marL="838200" indent="-228600">
+              <a:lnSpc>
+                <a:spcPct val="110000"/>
+              </a:lnSpc>
+              <a:spcBef>
+                <a:spcPts val="0"/>
+              </a:spcBef>
+              <a:spcAft>
+                <a:spcPts val="1200"/>
+              </a:spcAft>
+              <a:buChar char="•"/>
+            </a:lvl3pPr>
+            <a:lvl4pPr marL="1143000" indent="-228600">
+              <a:lnSpc>
+                <a:spcPct val="110000"/>
+              </a:lnSpc>
+              <a:spcBef>
+                <a:spcPts val="0"/>
+              </a:spcBef>
+              <a:spcAft>
+                <a:spcPts val="1200"/>
+              </a:spcAft>
+              <a:buChar char="•"/>
+            </a:lvl4pPr>
+            <a:lvl5pPr marL="1447800" indent="-228600">
+              <a:lnSpc>
+                <a:spcPct val="110000"/>
+              </a:lnSpc>
+              <a:spcBef>
+                <a:spcPts val="0"/>
+              </a:spcBef>
+              <a:spcAft>
+                <a:spcPts val="1200"/>
+              </a:spcAft>
+              <a:buChar char="•"/>
+            </a:lvl5pPr>
+            <a:lvl6pPr marL="1752600" indent="-228600">
+              <a:lnSpc>
+                <a:spcPct val="110000"/>
+              </a:lnSpc>
+              <a:spcBef>
+                <a:spcPts val="0"/>
+              </a:spcBef>
+              <a:spcAft>
+                <a:spcPts val="1200"/>
+              </a:spcAft>
+              <a:buChar char="•"/>
+            </a:lvl6pPr>
+            <a:lvl7pPr marL="2057400" indent="-228600">
+              <a:lnSpc>
+                <a:spcPct val="110000"/>
+              </a:lnSpc>
+              <a:spcBef>
+                <a:spcPts val="0"/>
+              </a:spcBef>
+              <a:spcAft>
+                <a:spcPts val="1200"/>
+              </a:spcAft>
+              <a:buChar char="•"/>
+            </a:lvl7pPr>
+            <a:lvl8pPr marL="2362200" indent="-228600">
+              <a:lnSpc>
+                <a:spcPct val="110000"/>
+              </a:lnSpc>
+              <a:spcBef>
+                <a:spcPts val="0"/>
+              </a:spcBef>
+              <a:spcAft>
+                <a:spcPts val="1200"/>
+              </a:spcAft>
+              <a:buChar char="•"/>
+            </a:lvl8pPr>
+            <a:lvl9pPr marL="2667000" indent="-228600">
+              <a:lnSpc>
+                <a:spcPct val="110000"/>
+              </a:lnSpc>
+              <a:spcBef>
+                <a:spcPts val="0"/>
+              </a:spcBef>
+              <a:spcAft>
+                <a:spcPts val="1200"/>
+              </a:spcAft>
+              <a:buChar char="•"/>
+            </a:lvl9pPr>
+          </a:lstStyle>
+          <a:p xmlns:a="http://schemas.openxmlformats.org/drawingml/2006/main"/>
+        </p:txBody>
+      </p:sp>
+      <p:sp>
+        <p:nvSpPr>
+          <p:cNvPr id="3" name="Right column">
+            <a:extLst xmlns:a="http://schemas.openxmlformats.org/drawingml/2006/main">
+              <a:ext uri="{FF2B5EF4-FFF2-40B4-BE49-F238E27FC236}">
+                <a16:creationId xmlns:a16="http://schemas.microsoft.com/office/drawing/2014/main" id="{B1AB21FD-B6AE-4018-BF9C-8A96CE82851F}"/>
+              </a:ext>
+            </a:extLst>
+          </p:cNvPr>
+          <p:cNvSpPr>
+            <a:spLocks xmlns:a="http://schemas.openxmlformats.org/drawingml/2006/main" noGrp="1"/>
+          </p:cNvSpPr>
+          <p:nvPr>
+            <p:ph type="body" idx="2"/>
+          </p:nvPr>
+        </p:nvSpPr>
+        <p:spPr>
+          <a:xfrm xmlns:a="http://schemas.openxmlformats.org/drawingml/2006/main">
+            <a:off x="6477000" y="1905000"/>
+            <a:ext cx="5029200" cy="4267200"/>
+          </a:xfrm>
+          <a:prstGeom xmlns:a="http://schemas.openxmlformats.org/drawingml/2006/main" prst="rect">
+            <a:avLst/>
+          </a:prstGeom>
+          <a:noFill xmlns:a="http://schemas.openxmlformats.org/drawingml/2006/main"/>
+          <a:ln xmlns:a="http://schemas.openxmlformats.org/drawingml/2006/main">
+            <a:noFill/>
+            <a:prstDash val="solid"/>
+          </a:ln>
+        </p:spPr>
+        <p:txBody>
+          <a:bodyPr xmlns:a="http://schemas.openxmlformats.org/drawingml/2006/main" wrap="square" lIns="0" tIns="0" rIns="0" bIns="0" anchor="t">
+            <a:normAutofit/>
+          </a:bodyPr>
+          <a:lstStyle xmlns:a="http://schemas.openxmlformats.org/drawingml/2006/main">
+            <a:defPPr algn="l">
+              <a:defRPr sz="2100" b="0">
+                <a:solidFill>
+                  <a:schemeClr val="tx1"/>
+                </a:solidFill>
+                <a:latin typeface="+mn-lt"/>
+                <a:ea typeface="+mn-lt"/>
+                <a:cs typeface="+mn-lt"/>
+              </a:defRPr>
+            </a:defPPr>
+            <a:lvl1pPr marL="228600" indent="-228600">
+              <a:lnSpc>
+                <a:spcPct val="110000"/>
+              </a:lnSpc>
+              <a:spcBef>
+                <a:spcPts val="0"/>
+              </a:spcBef>
+              <a:spcAft>
+                <a:spcPts val="1200"/>
+              </a:spcAft>
+              <a:buChar char="•"/>
+            </a:lvl1pPr>
+            <a:lvl2pPr marL="533400" indent="-228600">
+              <a:lnSpc>
+                <a:spcPct val="110000"/>
+              </a:lnSpc>
+              <a:spcBef>
+                <a:spcPts val="0"/>
+              </a:spcBef>
+              <a:spcAft>
+                <a:spcPts val="1200"/>
+              </a:spcAft>
+              <a:buChar char="•"/>
+            </a:lvl2pPr>
+            <a:lvl3pPr marL="838200" indent="-228600">
+              <a:lnSpc>
+                <a:spcPct val="110000"/>
+              </a:lnSpc>
+              <a:spcBef>
+                <a:spcPts val="0"/>
+              </a:spcBef>
+              <a:spcAft>
+                <a:spcPts val="1200"/>
+              </a:spcAft>
+              <a:buChar char="•"/>
+            </a:lvl3pPr>
+            <a:lvl4pPr marL="1143000" indent="-228600">
+              <a:lnSpc>
+                <a:spcPct val="110000"/>
+              </a:lnSpc>
+              <a:spcBef>
+                <a:spcPts val="0"/>
+              </a:spcBef>
+              <a:spcAft>
+                <a:spcPts val="1200"/>
+              </a:spcAft>
+              <a:buChar char="•"/>
+            </a:lvl4pPr>
+            <a:lvl5pPr marL="1447800" indent="-228600">
+              <a:lnSpc>
+                <a:spcPct val="110000"/>
+              </a:lnSpc>
+              <a:spcBef>
+                <a:spcPts val="0"/>
+              </a:spcBef>
+              <a:spcAft>
+                <a:spcPts val="1200"/>
+              </a:spcAft>
+              <a:buChar char="•"/>
+            </a:lvl5pPr>
+            <a:lvl6pPr marL="1752600" indent="-228600">
+              <a:lnSpc>
+                <a:spcPct val="110000"/>
+              </a:lnSpc>
+              <a:spcBef>
+                <a:spcPts val="0"/>
+              </a:spcBef>
+              <a:spcAft>
+                <a:spcPts val="1200"/>
+              </a:spcAft>
+              <a:buChar char="•"/>
+            </a:lvl6pPr>
+            <a:lvl7pPr marL="2057400" indent="-228600">
+              <a:lnSpc>
+                <a:spcPct val="110000"/>
+              </a:lnSpc>
+              <a:spcBef>
+                <a:spcPts val="0"/>
+              </a:spcBef>
+              <a:spcAft>
+                <a:spcPts val="1200"/>
+              </a:spcAft>
+              <a:buChar char="•"/>
+            </a:lvl7pPr>
+            <a:lvl8pPr marL="2362200" indent="-228600">
+              <a:lnSpc>
+                <a:spcPct val="110000"/>
+              </a:lnSpc>
+              <a:spcBef>
+                <a:spcPts val="0"/>
+              </a:spcBef>
+              <a:spcAft>
+                <a:spcPts val="1200"/>
+              </a:spcAft>
+              <a:buChar char="•"/>
+            </a:lvl8pPr>
+            <a:lvl9pPr marL="2667000" indent="-228600">
+              <a:lnSpc>
+                <a:spcPct val="110000"/>
+              </a:lnSpc>
+              <a:spcBef>
+                <a:spcPts val="0"/>
+              </a:spcBef>
+              <a:spcAft>
+                <a:spcPts val="1200"/>
+              </a:spcAft>
+              <a:buChar char="•"/>
+            </a:lvl9pPr>
+          </a:lstStyle>
+          <a:p xmlns:a="http://schemas.openxmlformats.org/drawingml/2006/main"/>
+        </p:txBody>
+      </p:sp>
+    </p:spTree>
+  </p:cSld>
+</p:sldLayout>
+</file>
+
+<file path=ppt/slideLayouts/slideLayout5.xml><?xml version="1.0" encoding="utf-8"?>
+<p:sldLayout xmlns:p="http://schemas.openxmlformats.org/presentationml/2006/main">
+  <p:cSld name="Title and One Column">
+    <p:spTree>
+      <p:nvGrpSpPr>
+        <p:cNvPr id="1" name=""/>
+        <p:cNvGrpSpPr/>
+        <p:nvPr/>
+      </p:nvGrpSpPr>
+      <p:grpSpPr>
+        <a:xfrm xmlns:a="http://schemas.openxmlformats.org/drawingml/2006/main"/>
+      </p:grpSpPr>
+      <p:sp>
+        <p:nvSpPr>
+          <p:cNvPr id="3" name="Title">
+            <a:extLst xmlns:a="http://schemas.openxmlformats.org/drawingml/2006/main">
+              <a:ext uri="{FF2B5EF4-FFF2-40B4-BE49-F238E27FC236}">
+                <a16:creationId xmlns:a16="http://schemas.microsoft.com/office/drawing/2014/main" id="{52F09AC7-9C7D-4D21-BDCE-44A97C5F0FA1}"/>
+              </a:ext>
+            </a:extLst>
+          </p:cNvPr>
+          <p:cNvSpPr>
+            <a:spLocks xmlns:a="http://schemas.openxmlformats.org/drawingml/2006/main" noGrp="1"/>
+          </p:cNvSpPr>
+          <p:nvPr>
+            <p:ph type="title" idx="0"/>
+          </p:nvPr>
+        </p:nvSpPr>
+        <p:spPr>
+          <a:xfrm xmlns:a="http://schemas.openxmlformats.org/drawingml/2006/main">
+            <a:off x="685800" y="533400"/>
+            <a:ext cx="10820400" cy="838200"/>
+          </a:xfrm>
+          <a:prstGeom xmlns:a="http://schemas.openxmlformats.org/drawingml/2006/main" prst="rect">
+            <a:avLst/>
+          </a:prstGeom>
+          <a:noFill xmlns:a="http://schemas.openxmlformats.org/drawingml/2006/main"/>
+          <a:ln xmlns:a="http://schemas.openxmlformats.org/drawingml/2006/main">
+            <a:noFill/>
+            <a:prstDash val="solid"/>
+          </a:ln>
+        </p:spPr>
+        <p:txBody>
+          <a:bodyPr xmlns:a="http://schemas.openxmlformats.org/drawingml/2006/main" wrap="square" lIns="0" tIns="0" rIns="0" bIns="0" anchor="t">
+            <a:normAutofit/>
+          </a:bodyPr>
+          <a:lstStyle xmlns:a="http://schemas.openxmlformats.org/drawingml/2006/main">
+            <a:defPPr algn="l">
+              <a:defRPr sz="3300" b="1">
+                <a:solidFill>
+                  <a:schemeClr val="tx1"/>
+                </a:solidFill>
+                <a:latin typeface="+mj-lt"/>
+                <a:ea typeface="+mj-lt"/>
+                <a:cs typeface="+mj-lt"/>
+              </a:defRPr>
+            </a:defPPr>
+            <a:lvl1pPr marL="0" indent="0">
+              <a:lnSpc>
+                <a:spcPct val="110000"/>
+              </a:lnSpc>
+              <a:spcBef>
+                <a:spcPts val="0"/>
+              </a:spcBef>
+              <a:spcAft>
+                <a:spcPts val="0"/>
+              </a:spcAft>
+              <a:buNone/>
+            </a:lvl1pPr>
+            <a:lvl2pPr marL="0" indent="0">
+              <a:lnSpc>
+                <a:spcPct val="110000"/>
+              </a:lnSpc>
+              <a:spcBef>
+                <a:spcPts val="0"/>
+              </a:spcBef>
+              <a:spcAft>
+                <a:spcPts val="0"/>
+              </a:spcAft>
+              <a:buNone/>
+            </a:lvl2pPr>
+            <a:lvl3pPr marL="0" indent="0">
+              <a:lnSpc>
+                <a:spcPct val="110000"/>
+              </a:lnSpc>
+              <a:spcBef>
+                <a:spcPts val="0"/>
+              </a:spcBef>
+              <a:spcAft>
+                <a:spcPts val="0"/>
+              </a:spcAft>
+              <a:buNone/>
+            </a:lvl3pPr>
+            <a:lvl4pPr marL="0" indent="0">
+              <a:lnSpc>
+                <a:spcPct val="110000"/>
+              </a:lnSpc>
+              <a:spcBef>
+                <a:spcPts val="0"/>
+              </a:spcBef>
+              <a:spcAft>
+                <a:spcPts val="0"/>
+              </a:spcAft>
+              <a:buNone/>
+            </a:lvl4pPr>
+            <a:lvl5pPr marL="0" indent="0">
+              <a:lnSpc>
+                <a:spcPct val="110000"/>
+              </a:lnSpc>
+              <a:spcBef>
+                <a:spcPts val="0"/>
+              </a:spcBef>
+              <a:spcAft>
+                <a:spcPts val="0"/>
+              </a:spcAft>
+              <a:buNone/>
+            </a:lvl5pPr>
+            <a:lvl6pPr marL="0" indent="0">
+              <a:lnSpc>
+                <a:spcPct val="110000"/>
+              </a:lnSpc>
+              <a:spcBef>
+                <a:spcPts val="0"/>
+              </a:spcBef>
+              <a:spcAft>
+                <a:spcPts val="0"/>
+              </a:spcAft>
+              <a:buNone/>
+            </a:lvl6pPr>
+            <a:lvl7pPr marL="0" indent="0">
+              <a:lnSpc>
+                <a:spcPct val="110000"/>
+              </a:lnSpc>
+              <a:spcBef>
+                <a:spcPts val="0"/>
+              </a:spcBef>
+              <a:spcAft>
+                <a:spcPts val="0"/>
+              </a:spcAft>
+              <a:buNone/>
+            </a:lvl7pPr>
+            <a:lvl8pPr marL="0" indent="0">
+              <a:lnSpc>
+                <a:spcPct val="110000"/>
+              </a:lnSpc>
+              <a:spcBef>
+                <a:spcPts val="0"/>
+              </a:spcBef>
+              <a:spcAft>
+                <a:spcPts val="0"/>
+              </a:spcAft>
+              <a:buNone/>
+            </a:lvl8pPr>
+            <a:lvl9pPr marL="0" indent="0">
+              <a:lnSpc>
+                <a:spcPct val="110000"/>
+              </a:lnSpc>
+              <a:spcBef>
+                <a:spcPts val="0"/>
+              </a:spcBef>
+              <a:spcAft>
+                <a:spcPts val="0"/>
+              </a:spcAft>
+              <a:buNone/>
+            </a:lvl9pPr>
+          </a:lstStyle>
+          <a:p xmlns:a="http://schemas.openxmlformats.org/drawingml/2006/main"/>
+        </p:txBody>
+      </p:sp>
+      <p:sp>
+        <p:nvSpPr>
+          <p:cNvPr id="2" name="Left column">
+            <a:extLst xmlns:a="http://schemas.openxmlformats.org/drawingml/2006/main">
+              <a:ext uri="{FF2B5EF4-FFF2-40B4-BE49-F238E27FC236}">
+                <a16:creationId xmlns:a16="http://schemas.microsoft.com/office/drawing/2014/main" id="{B1A89DAF-D675-4F37-BFB0-D57455704B13}"/>
+              </a:ext>
+            </a:extLst>
+          </p:cNvPr>
+          <p:cNvSpPr>
+            <a:spLocks xmlns:a="http://schemas.openxmlformats.org/drawingml/2006/main" noGrp="1"/>
+          </p:cNvSpPr>
+          <p:nvPr>
+            <p:ph type="body" idx="1"/>
+          </p:nvPr>
+        </p:nvSpPr>
+        <p:spPr>
+          <a:xfrm xmlns:a="http://schemas.openxmlformats.org/drawingml/2006/main">
+            <a:off x="685800" y="1905000"/>
+            <a:ext cx="5029200" cy="4267200"/>
+          </a:xfrm>
+          <a:prstGeom xmlns:a="http://schemas.openxmlformats.org/drawingml/2006/main" prst="rect">
+            <a:avLst/>
+          </a:prstGeom>
+          <a:noFill xmlns:a="http://schemas.openxmlformats.org/drawingml/2006/main"/>
+          <a:ln xmlns:a="http://schemas.openxmlformats.org/drawingml/2006/main">
+            <a:noFill/>
+            <a:prstDash val="solid"/>
+          </a:ln>
+        </p:spPr>
+        <p:txBody>
+          <a:bodyPr xmlns:a="http://schemas.openxmlformats.org/drawingml/2006/main" wrap="square" lIns="0" tIns="0" rIns="0" bIns="0" anchor="t">
+            <a:normAutofit/>
+          </a:bodyPr>
+          <a:lstStyle xmlns:a="http://schemas.openxmlformats.org/drawingml/2006/main">
+            <a:defPPr algn="l">
+              <a:defRPr sz="2250" b="0">
+                <a:solidFill>
+                  <a:schemeClr val="tx1"/>
+                </a:solidFill>
+                <a:latin typeface="+mn-lt"/>
+                <a:ea typeface="+mn-lt"/>
+                <a:cs typeface="+mn-lt"/>
+              </a:defRPr>
+            </a:defPPr>
+            <a:lvl1pPr marL="228600" indent="-228600">
+              <a:lnSpc>
+                <a:spcPct val="110000"/>
+              </a:lnSpc>
+              <a:spcBef>
+                <a:spcPts val="0"/>
+              </a:spcBef>
+              <a:spcAft>
+                <a:spcPts val="1200"/>
+              </a:spcAft>
+              <a:buChar char="•"/>
+            </a:lvl1pPr>
+            <a:lvl2pPr marL="533400" indent="-228600">
+              <a:lnSpc>
+                <a:spcPct val="110000"/>
+              </a:lnSpc>
+              <a:spcBef>
+                <a:spcPts val="0"/>
+              </a:spcBef>
+              <a:spcAft>
+                <a:spcPts val="1200"/>
+              </a:spcAft>
+              <a:buChar char="•"/>
+            </a:lvl2pPr>
+            <a:lvl3pPr marL="838200" indent="-228600">
+              <a:lnSpc>
+                <a:spcPct val="110000"/>
+              </a:lnSpc>
+              <a:spcBef>
+                <a:spcPts val="0"/>
+              </a:spcBef>
+              <a:spcAft>
+                <a:spcPts val="1200"/>
+              </a:spcAft>
+              <a:buChar char="•"/>
+            </a:lvl3pPr>
+            <a:lvl4pPr marL="1143000" indent="-228600">
+              <a:lnSpc>
+                <a:spcPct val="110000"/>
+              </a:lnSpc>
+              <a:spcBef>
+                <a:spcPts val="0"/>
+              </a:spcBef>
+              <a:spcAft>
+                <a:spcPts val="1200"/>
+              </a:spcAft>
+              <a:buChar char="•"/>
+            </a:lvl4pPr>
+            <a:lvl5pPr marL="1447800" indent="-228600">
+              <a:lnSpc>
+                <a:spcPct val="110000"/>
+              </a:lnSpc>
+              <a:spcBef>
+                <a:spcPts val="0"/>
+              </a:spcBef>
+              <a:spcAft>
+                <a:spcPts val="1200"/>
+              </a:spcAft>
+              <a:buChar char="•"/>
+            </a:lvl5pPr>
+            <a:lvl6pPr marL="1752600" indent="-228600">
+              <a:lnSpc>
+                <a:spcPct val="110000"/>
+              </a:lnSpc>
+              <a:spcBef>
+                <a:spcPts val="0"/>
+              </a:spcBef>
+              <a:spcAft>
+                <a:spcPts val="1200"/>
+              </a:spcAft>
+              <a:buChar char="•"/>
+            </a:lvl6pPr>
+            <a:lvl7pPr marL="2057400" indent="-228600">
+              <a:lnSpc>
+                <a:spcPct val="110000"/>
+              </a:lnSpc>
+              <a:spcBef>
+                <a:spcPts val="0"/>
+              </a:spcBef>
+              <a:spcAft>
+                <a:spcPts val="1200"/>
+              </a:spcAft>
+              <a:buChar char="•"/>
+            </a:lvl7pPr>
+            <a:lvl8pPr marL="2362200" indent="-228600">
+              <a:lnSpc>
+                <a:spcPct val="110000"/>
+              </a:lnSpc>
+              <a:spcBef>
+                <a:spcPts val="0"/>
+              </a:spcBef>
+              <a:spcAft>
+                <a:spcPts val="1200"/>
+              </a:spcAft>
+              <a:buChar char="•"/>
+            </a:lvl8pPr>
+            <a:lvl9pPr marL="2667000" indent="-228600">
+              <a:lnSpc>
+                <a:spcPct val="110000"/>
+              </a:lnSpc>
+              <a:spcBef>
+                <a:spcPts val="0"/>
+              </a:spcBef>
+              <a:spcAft>
+                <a:spcPts val="1200"/>
+              </a:spcAft>
+              <a:buChar char="•"/>
+            </a:lvl9pPr>
+          </a:lstStyle>
+          <a:p xmlns:a="http://schemas.openxmlformats.org/drawingml/2006/main"/>
+        </p:txBody>
+      </p:sp>
+    </p:spTree>
+  </p:cSld>
+</p:sldLayout>
+</file>
+
+<file path=ppt/slideLayouts/slideLayout6.xml><?xml version="1.0" encoding="utf-8"?>
+<p:sldLayout xmlns:p="http://schemas.openxmlformats.org/presentationml/2006/main" type="blank">
+  <p:cSld name="Blank">
+    <p:spTree>
+      <p:nvGrpSpPr>
+        <p:cNvPr id="1" name=""/>
+        <p:cNvGrpSpPr/>
+        <p:nvPr/>
+      </p:nvGrpSpPr>
+      <p:grpSpPr>
+        <a:xfrm xmlns:a="http://schemas.openxmlformats.org/drawingml/2006/main"/>
+      </p:grpSpPr>
     </p:spTree>
   </p:cSld>
 </p:sldLayout>
@@ -1199,7 +2854,12 @@
   </p:cSld>
   <p:clrMap bg1="lt1" tx1="dk1" bg2="lt2" tx2="dk2" accent1="accent1" accent2="accent2" accent3="accent3" accent4="accent4" accent5="accent5" accent6="accent6" hlink="hlink" folHlink="folHlink"/>
   <p:sldLayoutIdLst>
-    <p:sldLayoutId xmlns:r="http://schemas.openxmlformats.org/officeDocument/2006/relationships" id="2147483649" r:id="R0cf629dc12124d89"/>
+    <p:sldLayoutId xmlns:r="http://schemas.openxmlformats.org/officeDocument/2006/relationships" id="2147483649" r:id="R48d70a9a314d4dca"/>
+    <p:sldLayoutId xmlns:r="http://schemas.openxmlformats.org/officeDocument/2006/relationships" id="2147483650" r:id="Rfc9f0d7ba9684454"/>
+    <p:sldLayoutId xmlns:r="http://schemas.openxmlformats.org/officeDocument/2006/relationships" id="2147483651" r:id="R3b0decc8c3894f21"/>
+    <p:sldLayoutId xmlns:r="http://schemas.openxmlformats.org/officeDocument/2006/relationships" id="2147483652" r:id="R5cba929fcab24113"/>
+    <p:sldLayoutId xmlns:r="http://schemas.openxmlformats.org/officeDocument/2006/relationships" id="2147483653" r:id="Rbbd834059cd448e0"/>
+    <p:sldLayoutId xmlns:r="http://schemas.openxmlformats.org/officeDocument/2006/relationships" id="2147483654" r:id="R20c3b23e45c44a13"/>
   </p:sldLayoutIdLst>
   <p:txStyles>
     <p:titleStyle>
@@ -1522,16 +3182,16 @@
         <a:srgbClr val="96607D"/>
       </a:folHlink>
     </a:clrScheme>
-    <a:fontScheme name="Office">
+    <a:fontScheme name="">
       <a:majorFont>
-        <a:latin typeface="Calibri Light"/>
-        <a:ea typeface="Calibri Light"/>
-        <a:cs typeface="Calibri Light"/>
+        <a:latin typeface="Aptos"/>
+        <a:ea typeface=""/>
+        <a:cs typeface=""/>
       </a:majorFont>
       <a:minorFont>
-        <a:latin typeface="Calibri"/>
-        <a:ea typeface="Calibri"/>
-        <a:cs typeface="Calibri"/>
+        <a:latin typeface="Aptos"/>
+        <a:ea typeface=""/>
+        <a:cs typeface=""/>
       </a:minorFont>
     </a:fontScheme>
     <a:fmtScheme name="ChatGPT">
@@ -1750,7 +3410,7 @@
           <p:cNvPr id="5" name="">
             <a:extLst xmlns:a="http://schemas.openxmlformats.org/drawingml/2006/main">
               <a:ext uri="{FF2B5EF4-FFF2-40B4-BE49-F238E27FC236}">
-                <a16:creationId xmlns:a16="http://schemas.microsoft.com/office/drawing/2014/main" id="{697E6290-C797-46C1-AA56-FADFE45282E6}"/>
+                <a16:creationId xmlns:a16="http://schemas.microsoft.com/office/drawing/2014/main" id="{C1974349-4A22-4C0A-B397-D1C62D918432}"/>
               </a:ext>
             </a:extLst>
           </p:cNvPr>
@@ -1776,7 +3436,18 @@
           <a:bodyPr xmlns:a="http://schemas.openxmlformats.org/drawingml/2006/main" anchor="ctr">
             <a:noAutofit/>
           </a:bodyPr>
-          <a:lstStyle xmlns:a="http://schemas.openxmlformats.org/drawingml/2006/main"/>
+          <a:lstStyle xmlns:a="http://schemas.openxmlformats.org/drawingml/2006/main">
+            <a:defPPr algn="l">
+              <a:defRPr sz="2700" b="1">
+                <a:solidFill>
+                  <a:srgbClr val="161616"/>
+                </a:solidFill>
+                <a:latin typeface="Arial"/>
+                <a:ea typeface="Arial"/>
+                <a:cs typeface="Arial"/>
+              </a:defRPr>
+            </a:defPPr>
+          </a:lstStyle>
           <a:p xmlns:a="http://schemas.openxmlformats.org/drawingml/2006/main">
             <a:pPr algn="l">
               <a:defRPr sz="2700" b="1">
@@ -1807,7 +3478,7 @@
           <p:cNvPr id="2" name="">
             <a:extLst xmlns:a="http://schemas.openxmlformats.org/drawingml/2006/main">
               <a:ext uri="{FF2B5EF4-FFF2-40B4-BE49-F238E27FC236}">
-                <a16:creationId xmlns:a16="http://schemas.microsoft.com/office/drawing/2014/main" id="{2ED27E64-4A41-4700-88E9-9C1531C7DAA2}"/>
+                <a16:creationId xmlns:a16="http://schemas.microsoft.com/office/drawing/2014/main" id="{33A87FAF-A312-4DF0-B719-3504EBF750E0}"/>
               </a:ext>
             </a:extLst>
           </p:cNvPr>
@@ -1833,7 +3504,18 @@
           <a:bodyPr xmlns:a="http://schemas.openxmlformats.org/drawingml/2006/main">
             <a:noAutofit/>
           </a:bodyPr>
-          <a:lstStyle xmlns:a="http://schemas.openxmlformats.org/drawingml/2006/main"/>
+          <a:lstStyle xmlns:a="http://schemas.openxmlformats.org/drawingml/2006/main">
+            <a:defPPr>
+              <a:defRPr sz="3750" b="1">
+                <a:solidFill>
+                  <a:srgbClr val="161616"/>
+                </a:solidFill>
+                <a:latin typeface="Arial"/>
+                <a:ea typeface="Arial"/>
+                <a:cs typeface="Arial"/>
+              </a:defRPr>
+            </a:defPPr>
+          </a:lstStyle>
           <a:p xmlns:a="http://schemas.openxmlformats.org/drawingml/2006/main">
             <a:pPr>
               <a:defRPr sz="3750" b="1">
@@ -1864,7 +3546,7 @@
           <p:cNvPr id="3" name="">
             <a:extLst xmlns:a="http://schemas.openxmlformats.org/drawingml/2006/main">
               <a:ext uri="{FF2B5EF4-FFF2-40B4-BE49-F238E27FC236}">
-                <a16:creationId xmlns:a16="http://schemas.microsoft.com/office/drawing/2014/main" id="{A526088F-0772-46CD-9F4A-F74C826968D9}"/>
+                <a16:creationId xmlns:a16="http://schemas.microsoft.com/office/drawing/2014/main" id="{C1253C69-B5F3-41F5-BD66-656E6F8DDEAF}"/>
               </a:ext>
             </a:extLst>
           </p:cNvPr>
@@ -1890,7 +3572,18 @@
           <a:bodyPr xmlns:a="http://schemas.openxmlformats.org/drawingml/2006/main">
             <a:noAutofit/>
           </a:bodyPr>
-          <a:lstStyle xmlns:a="http://schemas.openxmlformats.org/drawingml/2006/main"/>
+          <a:lstStyle xmlns:a="http://schemas.openxmlformats.org/drawingml/2006/main">
+            <a:defPPr>
+              <a:defRPr sz="2250" b="0">
+                <a:solidFill>
+                  <a:srgbClr val="161616"/>
+                </a:solidFill>
+                <a:latin typeface="Arial"/>
+                <a:ea typeface="Arial"/>
+                <a:cs typeface="Arial"/>
+              </a:defRPr>
+            </a:defPPr>
+          </a:lstStyle>
           <a:p xmlns:a="http://schemas.openxmlformats.org/drawingml/2006/main">
             <a:pPr>
               <a:defRPr sz="2250" b="0">
@@ -1921,7 +3614,7 @@
           <p:cNvPr id="4" name="">
             <a:extLst xmlns:a="http://schemas.openxmlformats.org/drawingml/2006/main">
               <a:ext uri="{FF2B5EF4-FFF2-40B4-BE49-F238E27FC236}">
-                <a16:creationId xmlns:a16="http://schemas.microsoft.com/office/drawing/2014/main" id="{1A58FFA2-896A-4763-88B9-02952E0FC4A1}"/>
+                <a16:creationId xmlns:a16="http://schemas.microsoft.com/office/drawing/2014/main" id="{097FF119-8434-40A1-994A-28E7D8C49A79}"/>
               </a:ext>
             </a:extLst>
           </p:cNvPr>
@@ -1947,7 +3640,18 @@
           <a:bodyPr xmlns:a="http://schemas.openxmlformats.org/drawingml/2006/main">
             <a:noAutofit/>
           </a:bodyPr>
-          <a:lstStyle xmlns:a="http://schemas.openxmlformats.org/drawingml/2006/main"/>
+          <a:lstStyle xmlns:a="http://schemas.openxmlformats.org/drawingml/2006/main">
+            <a:defPPr>
+              <a:defRPr sz="1800" b="0">
+                <a:solidFill>
+                  <a:srgbClr val="161616"/>
+                </a:solidFill>
+                <a:latin typeface="Arial"/>
+                <a:ea typeface="Arial"/>
+                <a:cs typeface="Arial"/>
+              </a:defRPr>
+            </a:defPPr>
+          </a:lstStyle>
           <a:p xmlns:a="http://schemas.openxmlformats.org/drawingml/2006/main">
             <a:pPr>
               <a:defRPr sz="1800" b="0">
@@ -1999,7 +3703,7 @@
     </p:spTree>
     <p:extLst>
       <p:ext uri="{BB962C8B-B14F-4D97-AF65-F5344CB8AC3E}">
-        <p14:creationId xmlns:p14="http://schemas.microsoft.com/office/powerpoint/2010/main" val="1495567075"/>
+        <p14:creationId xmlns:p14="http://schemas.microsoft.com/office/powerpoint/2010/main" val="1158707033"/>
       </p:ext>
     </p:extLst>
   </p:cSld>
@@ -2030,7 +3734,7 @@
           <p:cNvPr id="7" name="">
             <a:extLst xmlns:a="http://schemas.openxmlformats.org/drawingml/2006/main">
               <a:ext uri="{FF2B5EF4-FFF2-40B4-BE49-F238E27FC236}">
-                <a16:creationId xmlns:a16="http://schemas.microsoft.com/office/drawing/2014/main" id="{6ACC0576-2890-41E3-B9DA-6EFDCAA77928}"/>
+                <a16:creationId xmlns:a16="http://schemas.microsoft.com/office/drawing/2014/main" id="{6CD5AD34-C613-400B-9979-F91572858253}"/>
               </a:ext>
             </a:extLst>
           </p:cNvPr>
@@ -2056,7 +3760,18 @@
           <a:bodyPr xmlns:a="http://schemas.openxmlformats.org/drawingml/2006/main" anchor="ctr">
             <a:noAutofit/>
           </a:bodyPr>
-          <a:lstStyle xmlns:a="http://schemas.openxmlformats.org/drawingml/2006/main"/>
+          <a:lstStyle xmlns:a="http://schemas.openxmlformats.org/drawingml/2006/main">
+            <a:defPPr algn="l">
+              <a:defRPr sz="2700" b="1">
+                <a:solidFill>
+                  <a:srgbClr val="161616"/>
+                </a:solidFill>
+                <a:latin typeface="Arial"/>
+                <a:ea typeface="Arial"/>
+                <a:cs typeface="Arial"/>
+              </a:defRPr>
+            </a:defPPr>
+          </a:lstStyle>
           <a:p xmlns:a="http://schemas.openxmlformats.org/drawingml/2006/main">
             <a:pPr algn="l">
               <a:defRPr sz="2700" b="1">
@@ -2087,7 +3802,7 @@
           <p:cNvPr id="2" name="">
             <a:extLst xmlns:a="http://schemas.openxmlformats.org/drawingml/2006/main">
               <a:ext uri="{FF2B5EF4-FFF2-40B4-BE49-F238E27FC236}">
-                <a16:creationId xmlns:a16="http://schemas.microsoft.com/office/drawing/2014/main" id="{B8E3303E-4EBA-4A33-8630-E7B2D3458F7B}"/>
+                <a16:creationId xmlns:a16="http://schemas.microsoft.com/office/drawing/2014/main" id="{AF894987-9711-43A6-90FF-0F99CCD47839}"/>
               </a:ext>
             </a:extLst>
           </p:cNvPr>
@@ -2113,7 +3828,18 @@
           <a:bodyPr xmlns:a="http://schemas.openxmlformats.org/drawingml/2006/main">
             <a:noAutofit/>
           </a:bodyPr>
-          <a:lstStyle xmlns:a="http://schemas.openxmlformats.org/drawingml/2006/main"/>
+          <a:lstStyle xmlns:a="http://schemas.openxmlformats.org/drawingml/2006/main">
+            <a:defPPr>
+              <a:defRPr sz="2175" b="0">
+                <a:solidFill>
+                  <a:srgbClr val="161616"/>
+                </a:solidFill>
+                <a:latin typeface="Arial"/>
+                <a:ea typeface="Arial"/>
+                <a:cs typeface="Arial"/>
+              </a:defRPr>
+            </a:defPPr>
+          </a:lstStyle>
           <a:p xmlns:a="http://schemas.openxmlformats.org/drawingml/2006/main">
             <a:pPr>
               <a:defRPr sz="2175" b="0">
@@ -2144,7 +3870,7 @@
           <p:cNvPr id="3" name="">
             <a:extLst xmlns:a="http://schemas.openxmlformats.org/drawingml/2006/main">
               <a:ext uri="{FF2B5EF4-FFF2-40B4-BE49-F238E27FC236}">
-                <a16:creationId xmlns:a16="http://schemas.microsoft.com/office/drawing/2014/main" id="{01253FB5-5591-45D6-8422-CF690FC8B83F}"/>
+                <a16:creationId xmlns:a16="http://schemas.microsoft.com/office/drawing/2014/main" id="{B28A8D22-033D-491A-B590-E97C8124AEC9}"/>
               </a:ext>
             </a:extLst>
           </p:cNvPr>
@@ -2170,7 +3896,18 @@
           <a:bodyPr xmlns:a="http://schemas.openxmlformats.org/drawingml/2006/main">
             <a:noAutofit/>
           </a:bodyPr>
-          <a:lstStyle xmlns:a="http://schemas.openxmlformats.org/drawingml/2006/main"/>
+          <a:lstStyle xmlns:a="http://schemas.openxmlformats.org/drawingml/2006/main">
+            <a:defPPr>
+              <a:defRPr sz="2175" b="0">
+                <a:solidFill>
+                  <a:srgbClr val="161616"/>
+                </a:solidFill>
+                <a:latin typeface="Arial"/>
+                <a:ea typeface="Arial"/>
+                <a:cs typeface="Arial"/>
+              </a:defRPr>
+            </a:defPPr>
+          </a:lstStyle>
           <a:p xmlns:a="http://schemas.openxmlformats.org/drawingml/2006/main">
             <a:pPr>
               <a:defRPr sz="2175" b="0">
@@ -2201,7 +3938,7 @@
           <p:cNvPr id="4" name="">
             <a:extLst xmlns:a="http://schemas.openxmlformats.org/drawingml/2006/main">
               <a:ext uri="{FF2B5EF4-FFF2-40B4-BE49-F238E27FC236}">
-                <a16:creationId xmlns:a16="http://schemas.microsoft.com/office/drawing/2014/main" id="{46522086-3BC2-4A73-844F-1B0C6E1D338A}"/>
+                <a16:creationId xmlns:a16="http://schemas.microsoft.com/office/drawing/2014/main" id="{4E64A133-AC01-44BF-95BD-DE27FEE2FE68}"/>
               </a:ext>
             </a:extLst>
           </p:cNvPr>
@@ -2227,7 +3964,18 @@
           <a:bodyPr xmlns:a="http://schemas.openxmlformats.org/drawingml/2006/main">
             <a:noAutofit/>
           </a:bodyPr>
-          <a:lstStyle xmlns:a="http://schemas.openxmlformats.org/drawingml/2006/main"/>
+          <a:lstStyle xmlns:a="http://schemas.openxmlformats.org/drawingml/2006/main">
+            <a:defPPr>
+              <a:defRPr sz="2175" b="0">
+                <a:solidFill>
+                  <a:srgbClr val="161616"/>
+                </a:solidFill>
+                <a:latin typeface="Arial"/>
+                <a:ea typeface="Arial"/>
+                <a:cs typeface="Arial"/>
+              </a:defRPr>
+            </a:defPPr>
+          </a:lstStyle>
           <a:p xmlns:a="http://schemas.openxmlformats.org/drawingml/2006/main">
             <a:pPr>
               <a:defRPr sz="2175" b="0">
@@ -2258,7 +4006,7 @@
           <p:cNvPr id="5" name="">
             <a:extLst xmlns:a="http://schemas.openxmlformats.org/drawingml/2006/main">
               <a:ext uri="{FF2B5EF4-FFF2-40B4-BE49-F238E27FC236}">
-                <a16:creationId xmlns:a16="http://schemas.microsoft.com/office/drawing/2014/main" id="{A8B64772-6727-48F1-B3B6-CCB4EDD5E5DD}"/>
+                <a16:creationId xmlns:a16="http://schemas.microsoft.com/office/drawing/2014/main" id="{0726C77D-36BC-4908-8B2D-B5DAE3EFB3E8}"/>
               </a:ext>
             </a:extLst>
           </p:cNvPr>
@@ -2284,7 +4032,18 @@
           <a:bodyPr xmlns:a="http://schemas.openxmlformats.org/drawingml/2006/main">
             <a:noAutofit/>
           </a:bodyPr>
-          <a:lstStyle xmlns:a="http://schemas.openxmlformats.org/drawingml/2006/main"/>
+          <a:lstStyle xmlns:a="http://schemas.openxmlformats.org/drawingml/2006/main">
+            <a:defPPr>
+              <a:defRPr sz="2175" b="0">
+                <a:solidFill>
+                  <a:srgbClr val="161616"/>
+                </a:solidFill>
+                <a:latin typeface="Arial"/>
+                <a:ea typeface="Arial"/>
+                <a:cs typeface="Arial"/>
+              </a:defRPr>
+            </a:defPPr>
+          </a:lstStyle>
           <a:p xmlns:a="http://schemas.openxmlformats.org/drawingml/2006/main">
             <a:pPr>
               <a:defRPr sz="2175" b="0">
@@ -2315,7 +4074,7 @@
           <p:cNvPr id="6" name="">
             <a:extLst xmlns:a="http://schemas.openxmlformats.org/drawingml/2006/main">
               <a:ext uri="{FF2B5EF4-FFF2-40B4-BE49-F238E27FC236}">
-                <a16:creationId xmlns:a16="http://schemas.microsoft.com/office/drawing/2014/main" id="{C5BE58CE-0DDE-4C44-9AFC-3598A253897D}"/>
+                <a16:creationId xmlns:a16="http://schemas.microsoft.com/office/drawing/2014/main" id="{6308A342-D31F-4C7B-917B-E53BFC69B81F}"/>
               </a:ext>
             </a:extLst>
           </p:cNvPr>
@@ -2341,7 +4100,18 @@
           <a:bodyPr xmlns:a="http://schemas.openxmlformats.org/drawingml/2006/main">
             <a:noAutofit/>
           </a:bodyPr>
-          <a:lstStyle xmlns:a="http://schemas.openxmlformats.org/drawingml/2006/main"/>
+          <a:lstStyle xmlns:a="http://schemas.openxmlformats.org/drawingml/2006/main">
+            <a:defPPr>
+              <a:defRPr sz="2175" b="0">
+                <a:solidFill>
+                  <a:srgbClr val="161616"/>
+                </a:solidFill>
+                <a:latin typeface="Arial"/>
+                <a:ea typeface="Arial"/>
+                <a:cs typeface="Arial"/>
+              </a:defRPr>
+            </a:defPPr>
+          </a:lstStyle>
           <a:p xmlns:a="http://schemas.openxmlformats.org/drawingml/2006/main">
             <a:pPr>
               <a:defRPr sz="2175" b="0">
@@ -2370,7 +4140,7 @@
     </p:spTree>
     <p:extLst>
       <p:ext uri="{BB962C8B-B14F-4D97-AF65-F5344CB8AC3E}">
-        <p14:creationId xmlns:p14="http://schemas.microsoft.com/office/powerpoint/2010/main" val="2038280515"/>
+        <p14:creationId xmlns:p14="http://schemas.microsoft.com/office/powerpoint/2010/main" val="1713897783"/>
       </p:ext>
     </p:extLst>
   </p:cSld>
@@ -2401,7 +4171,7 @@
           <p:cNvPr id="3" name="">
             <a:extLst xmlns:a="http://schemas.openxmlformats.org/drawingml/2006/main">
               <a:ext uri="{FF2B5EF4-FFF2-40B4-BE49-F238E27FC236}">
-                <a16:creationId xmlns:a16="http://schemas.microsoft.com/office/drawing/2014/main" id="{983D7EE6-972D-4AC6-B079-5067135AD2E2}"/>
+                <a16:creationId xmlns:a16="http://schemas.microsoft.com/office/drawing/2014/main" id="{3B209719-1DD4-450F-9D43-A694E87DFFEF}"/>
               </a:ext>
             </a:extLst>
           </p:cNvPr>
@@ -2427,7 +4197,18 @@
           <a:bodyPr xmlns:a="http://schemas.openxmlformats.org/drawingml/2006/main" anchor="ctr">
             <a:noAutofit/>
           </a:bodyPr>
-          <a:lstStyle xmlns:a="http://schemas.openxmlformats.org/drawingml/2006/main"/>
+          <a:lstStyle xmlns:a="http://schemas.openxmlformats.org/drawingml/2006/main">
+            <a:defPPr algn="l">
+              <a:defRPr sz="2700" b="1">
+                <a:solidFill>
+                  <a:srgbClr val="161616"/>
+                </a:solidFill>
+                <a:latin typeface="Arial"/>
+                <a:ea typeface="Arial"/>
+                <a:cs typeface="Arial"/>
+              </a:defRPr>
+            </a:defPPr>
+          </a:lstStyle>
           <a:p xmlns:a="http://schemas.openxmlformats.org/drawingml/2006/main">
             <a:pPr algn="l">
               <a:defRPr sz="2700" b="1">
@@ -2455,7 +4236,13 @@
       </p:sp>
       <p:graphicFrame>
         <p:nvGraphicFramePr>
-          <p:cNvPr id="4" name=""/>
+          <p:cNvPr id="2" name="">
+            <a:extLst xmlns:a="http://schemas.openxmlformats.org/drawingml/2006/main">
+              <a:ext uri="{FF2B5EF4-FFF2-40B4-BE49-F238E27FC236}">
+                <a16:creationId xmlns:a16="http://schemas.microsoft.com/office/drawing/2014/main" id="{4B49E808-CDF7-4ACF-B316-8C58659F59FF}"/>
+              </a:ext>
+            </a:extLst>
+          </p:cNvPr>
           <p:cNvGraphicFramePr/>
           <p:nvPr/>
         </p:nvGraphicFramePr>
@@ -2492,6 +4279,30 @@
                     </a:p>
                   </a:txBody>
                   <a:tcPr marL="91440" marR="91440" marT="45720" marB="45720">
+                    <a:lnL w="9525">
+                      <a:solidFill>
+                        <a:srgbClr val="888888"/>
+                      </a:solidFill>
+                      <a:prstDash val="solid"/>
+                    </a:lnL>
+                    <a:lnR w="9525">
+                      <a:solidFill>
+                        <a:srgbClr val="888888"/>
+                      </a:solidFill>
+                      <a:prstDash val="solid"/>
+                    </a:lnR>
+                    <a:lnT w="9525">
+                      <a:solidFill>
+                        <a:srgbClr val="888888"/>
+                      </a:solidFill>
+                      <a:prstDash val="solid"/>
+                    </a:lnT>
+                    <a:lnB w="9525">
+                      <a:solidFill>
+                        <a:srgbClr val="888888"/>
+                      </a:solidFill>
+                      <a:prstDash val="solid"/>
+                    </a:lnB>
                     <a:solidFill>
                       <a:srgbClr val="F1F1F1"/>
                     </a:solidFill>
@@ -2516,6 +4327,24 @@
                     </a:p>
                   </a:txBody>
                   <a:tcPr marL="91440" marR="91440" marT="45720" marB="45720">
+                    <a:lnR w="9525">
+                      <a:solidFill>
+                        <a:srgbClr val="888888"/>
+                      </a:solidFill>
+                      <a:prstDash val="solid"/>
+                    </a:lnR>
+                    <a:lnT w="9525">
+                      <a:solidFill>
+                        <a:srgbClr val="888888"/>
+                      </a:solidFill>
+                      <a:prstDash val="solid"/>
+                    </a:lnT>
+                    <a:lnB w="9525">
+                      <a:solidFill>
+                        <a:srgbClr val="888888"/>
+                      </a:solidFill>
+                      <a:prstDash val="solid"/>
+                    </a:lnB>
                     <a:solidFill>
                       <a:srgbClr val="F1F1F1"/>
                     </a:solidFill>
@@ -2540,6 +4369,24 @@
                     </a:p>
                   </a:txBody>
                   <a:tcPr marL="91440" marR="91440" marT="45720" marB="45720">
+                    <a:lnR w="9525">
+                      <a:solidFill>
+                        <a:srgbClr val="888888"/>
+                      </a:solidFill>
+                      <a:prstDash val="solid"/>
+                    </a:lnR>
+                    <a:lnT w="9525">
+                      <a:solidFill>
+                        <a:srgbClr val="888888"/>
+                      </a:solidFill>
+                      <a:prstDash val="solid"/>
+                    </a:lnT>
+                    <a:lnB w="9525">
+                      <a:solidFill>
+                        <a:srgbClr val="888888"/>
+                      </a:solidFill>
+                      <a:prstDash val="solid"/>
+                    </a:lnB>
                     <a:solidFill>
                       <a:srgbClr val="F1F1F1"/>
                     </a:solidFill>
@@ -2566,6 +4413,24 @@
                     </a:p>
                   </a:txBody>
                   <a:tcPr marL="91440" marR="91440" marT="45720" marB="45720">
+                    <a:lnL w="9525">
+                      <a:solidFill>
+                        <a:srgbClr val="888888"/>
+                      </a:solidFill>
+                      <a:prstDash val="solid"/>
+                    </a:lnL>
+                    <a:lnR w="9525">
+                      <a:solidFill>
+                        <a:srgbClr val="888888"/>
+                      </a:solidFill>
+                      <a:prstDash val="solid"/>
+                    </a:lnR>
+                    <a:lnB w="9525">
+                      <a:solidFill>
+                        <a:srgbClr val="888888"/>
+                      </a:solidFill>
+                      <a:prstDash val="solid"/>
+                    </a:lnB>
                     <a:solidFill>
                       <a:srgbClr val="FFFFFF"/>
                     </a:solidFill>
@@ -2590,6 +4455,18 @@
                     </a:p>
                   </a:txBody>
                   <a:tcPr marL="91440" marR="91440" marT="45720" marB="45720">
+                    <a:lnR w="9525">
+                      <a:solidFill>
+                        <a:srgbClr val="888888"/>
+                      </a:solidFill>
+                      <a:prstDash val="solid"/>
+                    </a:lnR>
+                    <a:lnB w="9525">
+                      <a:solidFill>
+                        <a:srgbClr val="888888"/>
+                      </a:solidFill>
+                      <a:prstDash val="solid"/>
+                    </a:lnB>
                     <a:solidFill>
                       <a:srgbClr val="FFFFFF"/>
                     </a:solidFill>
@@ -2614,6 +4491,18 @@
                     </a:p>
                   </a:txBody>
                   <a:tcPr marL="91440" marR="91440" marT="45720" marB="45720">
+                    <a:lnR w="9525">
+                      <a:solidFill>
+                        <a:srgbClr val="888888"/>
+                      </a:solidFill>
+                      <a:prstDash val="solid"/>
+                    </a:lnR>
+                    <a:lnB w="9525">
+                      <a:solidFill>
+                        <a:srgbClr val="888888"/>
+                      </a:solidFill>
+                      <a:prstDash val="solid"/>
+                    </a:lnB>
                     <a:solidFill>
                       <a:srgbClr val="FFFFFF"/>
                     </a:solidFill>
@@ -2640,6 +4529,24 @@
                     </a:p>
                   </a:txBody>
                   <a:tcPr marL="91440" marR="91440" marT="45720" marB="45720">
+                    <a:lnL w="9525">
+                      <a:solidFill>
+                        <a:srgbClr val="888888"/>
+                      </a:solidFill>
+                      <a:prstDash val="solid"/>
+                    </a:lnL>
+                    <a:lnR w="9525">
+                      <a:solidFill>
+                        <a:srgbClr val="888888"/>
+                      </a:solidFill>
+                      <a:prstDash val="solid"/>
+                    </a:lnR>
+                    <a:lnB w="9525">
+                      <a:solidFill>
+                        <a:srgbClr val="888888"/>
+                      </a:solidFill>
+                      <a:prstDash val="solid"/>
+                    </a:lnB>
                     <a:solidFill>
                       <a:srgbClr val="FFFFFF"/>
                     </a:solidFill>
@@ -2664,6 +4571,18 @@
                     </a:p>
                   </a:txBody>
                   <a:tcPr marL="91440" marR="91440" marT="45720" marB="45720">
+                    <a:lnR w="9525">
+                      <a:solidFill>
+                        <a:srgbClr val="888888"/>
+                      </a:solidFill>
+                      <a:prstDash val="solid"/>
+                    </a:lnR>
+                    <a:lnB w="9525">
+                      <a:solidFill>
+                        <a:srgbClr val="888888"/>
+                      </a:solidFill>
+                      <a:prstDash val="solid"/>
+                    </a:lnB>
                     <a:solidFill>
                       <a:srgbClr val="FFFFFF"/>
                     </a:solidFill>
@@ -2688,6 +4607,18 @@
                     </a:p>
                   </a:txBody>
                   <a:tcPr marL="91440" marR="91440" marT="45720" marB="45720">
+                    <a:lnR w="9525">
+                      <a:solidFill>
+                        <a:srgbClr val="888888"/>
+                      </a:solidFill>
+                      <a:prstDash val="solid"/>
+                    </a:lnR>
+                    <a:lnB w="9525">
+                      <a:solidFill>
+                        <a:srgbClr val="888888"/>
+                      </a:solidFill>
+                      <a:prstDash val="solid"/>
+                    </a:lnB>
                     <a:solidFill>
                       <a:srgbClr val="FFFFFF"/>
                     </a:solidFill>
@@ -2714,6 +4645,24 @@
                     </a:p>
                   </a:txBody>
                   <a:tcPr marL="91440" marR="91440" marT="45720" marB="45720">
+                    <a:lnL w="9525">
+                      <a:solidFill>
+                        <a:srgbClr val="888888"/>
+                      </a:solidFill>
+                      <a:prstDash val="solid"/>
+                    </a:lnL>
+                    <a:lnR w="9525">
+                      <a:solidFill>
+                        <a:srgbClr val="888888"/>
+                      </a:solidFill>
+                      <a:prstDash val="solid"/>
+                    </a:lnR>
+                    <a:lnB w="9525">
+                      <a:solidFill>
+                        <a:srgbClr val="888888"/>
+                      </a:solidFill>
+                      <a:prstDash val="solid"/>
+                    </a:lnB>
                     <a:solidFill>
                       <a:srgbClr val="FFFFFF"/>
                     </a:solidFill>
@@ -2738,6 +4687,18 @@
                     </a:p>
                   </a:txBody>
                   <a:tcPr marL="91440" marR="91440" marT="45720" marB="45720">
+                    <a:lnR w="9525">
+                      <a:solidFill>
+                        <a:srgbClr val="888888"/>
+                      </a:solidFill>
+                      <a:prstDash val="solid"/>
+                    </a:lnR>
+                    <a:lnB w="9525">
+                      <a:solidFill>
+                        <a:srgbClr val="888888"/>
+                      </a:solidFill>
+                      <a:prstDash val="solid"/>
+                    </a:lnB>
                     <a:solidFill>
                       <a:srgbClr val="FFFFFF"/>
                     </a:solidFill>
@@ -2762,6 +4723,18 @@
                     </a:p>
                   </a:txBody>
                   <a:tcPr marL="91440" marR="91440" marT="45720" marB="45720">
+                    <a:lnR w="9525">
+                      <a:solidFill>
+                        <a:srgbClr val="888888"/>
+                      </a:solidFill>
+                      <a:prstDash val="solid"/>
+                    </a:lnR>
+                    <a:lnB w="9525">
+                      <a:solidFill>
+                        <a:srgbClr val="888888"/>
+                      </a:solidFill>
+                      <a:prstDash val="solid"/>
+                    </a:lnB>
                     <a:solidFill>
                       <a:srgbClr val="FFFFFF"/>
                     </a:solidFill>
@@ -2788,6 +4761,24 @@
                     </a:p>
                   </a:txBody>
                   <a:tcPr marL="91440" marR="91440" marT="45720" marB="45720">
+                    <a:lnL w="9525">
+                      <a:solidFill>
+                        <a:srgbClr val="888888"/>
+                      </a:solidFill>
+                      <a:prstDash val="solid"/>
+                    </a:lnL>
+                    <a:lnR w="9525">
+                      <a:solidFill>
+                        <a:srgbClr val="888888"/>
+                      </a:solidFill>
+                      <a:prstDash val="solid"/>
+                    </a:lnR>
+                    <a:lnB w="9525">
+                      <a:solidFill>
+                        <a:srgbClr val="888888"/>
+                      </a:solidFill>
+                      <a:prstDash val="solid"/>
+                    </a:lnB>
                     <a:solidFill>
                       <a:srgbClr val="FFFFFF"/>
                     </a:solidFill>
@@ -2812,6 +4803,18 @@
                     </a:p>
                   </a:txBody>
                   <a:tcPr marL="91440" marR="91440" marT="45720" marB="45720">
+                    <a:lnR w="9525">
+                      <a:solidFill>
+                        <a:srgbClr val="888888"/>
+                      </a:solidFill>
+                      <a:prstDash val="solid"/>
+                    </a:lnR>
+                    <a:lnB w="9525">
+                      <a:solidFill>
+                        <a:srgbClr val="888888"/>
+                      </a:solidFill>
+                      <a:prstDash val="solid"/>
+                    </a:lnB>
                     <a:solidFill>
                       <a:srgbClr val="FFFFFF"/>
                     </a:solidFill>
@@ -2836,6 +4839,18 @@
                     </a:p>
                   </a:txBody>
                   <a:tcPr marL="91440" marR="91440" marT="45720" marB="45720">
+                    <a:lnR w="9525">
+                      <a:solidFill>
+                        <a:srgbClr val="888888"/>
+                      </a:solidFill>
+                      <a:prstDash val="solid"/>
+                    </a:lnR>
+                    <a:lnB w="9525">
+                      <a:solidFill>
+                        <a:srgbClr val="888888"/>
+                      </a:solidFill>
+                      <a:prstDash val="solid"/>
+                    </a:lnB>
                     <a:solidFill>
                       <a:srgbClr val="FFFFFF"/>
                     </a:solidFill>
@@ -2862,6 +4877,24 @@
                     </a:p>
                   </a:txBody>
                   <a:tcPr marL="91440" marR="91440" marT="45720" marB="45720">
+                    <a:lnL w="9525">
+                      <a:solidFill>
+                        <a:srgbClr val="888888"/>
+                      </a:solidFill>
+                      <a:prstDash val="solid"/>
+                    </a:lnL>
+                    <a:lnR w="9525">
+                      <a:solidFill>
+                        <a:srgbClr val="888888"/>
+                      </a:solidFill>
+                      <a:prstDash val="solid"/>
+                    </a:lnR>
+                    <a:lnB w="9525">
+                      <a:solidFill>
+                        <a:srgbClr val="888888"/>
+                      </a:solidFill>
+                      <a:prstDash val="solid"/>
+                    </a:lnB>
                     <a:solidFill>
                       <a:srgbClr val="FFFFFF"/>
                     </a:solidFill>
@@ -2886,6 +4919,18 @@
                     </a:p>
                   </a:txBody>
                   <a:tcPr marL="91440" marR="91440" marT="45720" marB="45720">
+                    <a:lnR w="9525">
+                      <a:solidFill>
+                        <a:srgbClr val="888888"/>
+                      </a:solidFill>
+                      <a:prstDash val="solid"/>
+                    </a:lnR>
+                    <a:lnB w="9525">
+                      <a:solidFill>
+                        <a:srgbClr val="888888"/>
+                      </a:solidFill>
+                      <a:prstDash val="solid"/>
+                    </a:lnB>
                     <a:solidFill>
                       <a:srgbClr val="FFFFFF"/>
                     </a:solidFill>
@@ -2910,6 +4955,18 @@
                     </a:p>
                   </a:txBody>
                   <a:tcPr marL="91440" marR="91440" marT="45720" marB="45720">
+                    <a:lnR w="9525">
+                      <a:solidFill>
+                        <a:srgbClr val="888888"/>
+                      </a:solidFill>
+                      <a:prstDash val="solid"/>
+                    </a:lnR>
+                    <a:lnB w="9525">
+                      <a:solidFill>
+                        <a:srgbClr val="888888"/>
+                      </a:solidFill>
+                      <a:prstDash val="solid"/>
+                    </a:lnB>
                     <a:solidFill>
                       <a:srgbClr val="FFFFFF"/>
                     </a:solidFill>
@@ -2936,6 +4993,24 @@
                     </a:p>
                   </a:txBody>
                   <a:tcPr marL="91440" marR="91440" marT="45720" marB="45720">
+                    <a:lnL w="9525">
+                      <a:solidFill>
+                        <a:srgbClr val="888888"/>
+                      </a:solidFill>
+                      <a:prstDash val="solid"/>
+                    </a:lnL>
+                    <a:lnR w="9525">
+                      <a:solidFill>
+                        <a:srgbClr val="888888"/>
+                      </a:solidFill>
+                      <a:prstDash val="solid"/>
+                    </a:lnR>
+                    <a:lnB w="9525">
+                      <a:solidFill>
+                        <a:srgbClr val="888888"/>
+                      </a:solidFill>
+                      <a:prstDash val="solid"/>
+                    </a:lnB>
                     <a:solidFill>
                       <a:srgbClr val="FFFFFF"/>
                     </a:solidFill>
@@ -2960,6 +5035,18 @@
                     </a:p>
                   </a:txBody>
                   <a:tcPr marL="91440" marR="91440" marT="45720" marB="45720">
+                    <a:lnR w="9525">
+                      <a:solidFill>
+                        <a:srgbClr val="888888"/>
+                      </a:solidFill>
+                      <a:prstDash val="solid"/>
+                    </a:lnR>
+                    <a:lnB w="9525">
+                      <a:solidFill>
+                        <a:srgbClr val="888888"/>
+                      </a:solidFill>
+                      <a:prstDash val="solid"/>
+                    </a:lnB>
                     <a:solidFill>
                       <a:srgbClr val="FFFFFF"/>
                     </a:solidFill>
@@ -2984,6 +5071,18 @@
                     </a:p>
                   </a:txBody>
                   <a:tcPr marL="91440" marR="91440" marT="45720" marB="45720">
+                    <a:lnR w="9525">
+                      <a:solidFill>
+                        <a:srgbClr val="888888"/>
+                      </a:solidFill>
+                      <a:prstDash val="solid"/>
+                    </a:lnR>
+                    <a:lnB w="9525">
+                      <a:solidFill>
+                        <a:srgbClr val="888888"/>
+                      </a:solidFill>
+                      <a:prstDash val="solid"/>
+                    </a:lnB>
                     <a:solidFill>
                       <a:srgbClr val="FFFFFF"/>
                     </a:solidFill>
@@ -3010,6 +5109,24 @@
                     </a:p>
                   </a:txBody>
                   <a:tcPr marL="91440" marR="91440" marT="45720" marB="45720">
+                    <a:lnL w="9525">
+                      <a:solidFill>
+                        <a:srgbClr val="888888"/>
+                      </a:solidFill>
+                      <a:prstDash val="solid"/>
+                    </a:lnL>
+                    <a:lnR w="9525">
+                      <a:solidFill>
+                        <a:srgbClr val="888888"/>
+                      </a:solidFill>
+                      <a:prstDash val="solid"/>
+                    </a:lnR>
+                    <a:lnB w="9525">
+                      <a:solidFill>
+                        <a:srgbClr val="888888"/>
+                      </a:solidFill>
+                      <a:prstDash val="solid"/>
+                    </a:lnB>
                     <a:solidFill>
                       <a:srgbClr val="FFFFFF"/>
                     </a:solidFill>
@@ -3034,6 +5151,18 @@
                     </a:p>
                   </a:txBody>
                   <a:tcPr marL="91440" marR="91440" marT="45720" marB="45720">
+                    <a:lnR w="9525">
+                      <a:solidFill>
+                        <a:srgbClr val="888888"/>
+                      </a:solidFill>
+                      <a:prstDash val="solid"/>
+                    </a:lnR>
+                    <a:lnB w="9525">
+                      <a:solidFill>
+                        <a:srgbClr val="888888"/>
+                      </a:solidFill>
+                      <a:prstDash val="solid"/>
+                    </a:lnB>
                     <a:solidFill>
                       <a:srgbClr val="FFFFFF"/>
                     </a:solidFill>
@@ -3058,6 +5187,18 @@
                     </a:p>
                   </a:txBody>
                   <a:tcPr marL="91440" marR="91440" marT="45720" marB="45720">
+                    <a:lnR w="9525">
+                      <a:solidFill>
+                        <a:srgbClr val="888888"/>
+                      </a:solidFill>
+                      <a:prstDash val="solid"/>
+                    </a:lnR>
+                    <a:lnB w="9525">
+                      <a:solidFill>
+                        <a:srgbClr val="888888"/>
+                      </a:solidFill>
+                      <a:prstDash val="solid"/>
+                    </a:lnB>
                     <a:solidFill>
                       <a:srgbClr val="FFFFFF"/>
                     </a:solidFill>
@@ -3084,6 +5225,24 @@
                     </a:p>
                   </a:txBody>
                   <a:tcPr marL="91440" marR="91440" marT="45720" marB="45720">
+                    <a:lnL w="9525">
+                      <a:solidFill>
+                        <a:srgbClr val="888888"/>
+                      </a:solidFill>
+                      <a:prstDash val="solid"/>
+                    </a:lnL>
+                    <a:lnR w="9525">
+                      <a:solidFill>
+                        <a:srgbClr val="888888"/>
+                      </a:solidFill>
+                      <a:prstDash val="solid"/>
+                    </a:lnR>
+                    <a:lnB w="9525">
+                      <a:solidFill>
+                        <a:srgbClr val="888888"/>
+                      </a:solidFill>
+                      <a:prstDash val="solid"/>
+                    </a:lnB>
                     <a:solidFill>
                       <a:srgbClr val="FFFFFF"/>
                     </a:solidFill>
@@ -3108,6 +5267,18 @@
                     </a:p>
                   </a:txBody>
                   <a:tcPr marL="91440" marR="91440" marT="45720" marB="45720">
+                    <a:lnR w="9525">
+                      <a:solidFill>
+                        <a:srgbClr val="888888"/>
+                      </a:solidFill>
+                      <a:prstDash val="solid"/>
+                    </a:lnR>
+                    <a:lnB w="9525">
+                      <a:solidFill>
+                        <a:srgbClr val="888888"/>
+                      </a:solidFill>
+                      <a:prstDash val="solid"/>
+                    </a:lnB>
                     <a:solidFill>
                       <a:srgbClr val="FFFFFF"/>
                     </a:solidFill>
@@ -3132,6 +5303,18 @@
                     </a:p>
                   </a:txBody>
                   <a:tcPr marL="91440" marR="91440" marT="45720" marB="45720">
+                    <a:lnR w="9525">
+                      <a:solidFill>
+                        <a:srgbClr val="888888"/>
+                      </a:solidFill>
+                      <a:prstDash val="solid"/>
+                    </a:lnR>
+                    <a:lnB w="9525">
+                      <a:solidFill>
+                        <a:srgbClr val="888888"/>
+                      </a:solidFill>
+                      <a:prstDash val="solid"/>
+                    </a:lnB>
                     <a:solidFill>
                       <a:srgbClr val="FFFFFF"/>
                     </a:solidFill>
@@ -3145,7 +5328,7 @@
     </p:spTree>
     <p:extLst>
       <p:ext uri="{BB962C8B-B14F-4D97-AF65-F5344CB8AC3E}">
-        <p14:creationId xmlns:p14="http://schemas.microsoft.com/office/powerpoint/2010/main" val="432924695"/>
+        <p14:creationId xmlns:p14="http://schemas.microsoft.com/office/powerpoint/2010/main" val="28158232"/>
       </p:ext>
     </p:extLst>
   </p:cSld>
@@ -3176,7 +5359,7 @@
           <p:cNvPr id="3" name="">
             <a:extLst xmlns:a="http://schemas.openxmlformats.org/drawingml/2006/main">
               <a:ext uri="{FF2B5EF4-FFF2-40B4-BE49-F238E27FC236}">
-                <a16:creationId xmlns:a16="http://schemas.microsoft.com/office/drawing/2014/main" id="{41F6FCC6-ABF2-4F4D-B703-8FAC07A2D297}"/>
+                <a16:creationId xmlns:a16="http://schemas.microsoft.com/office/drawing/2014/main" id="{4FED8F12-638E-430A-9B82-9DDA0CC31A7F}"/>
               </a:ext>
             </a:extLst>
           </p:cNvPr>
@@ -3202,7 +5385,18 @@
           <a:bodyPr xmlns:a="http://schemas.openxmlformats.org/drawingml/2006/main" anchor="ctr">
             <a:noAutofit/>
           </a:bodyPr>
-          <a:lstStyle xmlns:a="http://schemas.openxmlformats.org/drawingml/2006/main"/>
+          <a:lstStyle xmlns:a="http://schemas.openxmlformats.org/drawingml/2006/main">
+            <a:defPPr algn="l">
+              <a:defRPr sz="2700" b="1">
+                <a:solidFill>
+                  <a:srgbClr val="161616"/>
+                </a:solidFill>
+                <a:latin typeface="Arial"/>
+                <a:ea typeface="Arial"/>
+                <a:cs typeface="Arial"/>
+              </a:defRPr>
+            </a:defPPr>
+          </a:lstStyle>
           <a:p xmlns:a="http://schemas.openxmlformats.org/drawingml/2006/main">
             <a:pPr algn="l">
               <a:defRPr sz="2700" b="1">
@@ -3223,21 +5417,27 @@
                 <a:ea typeface="Arial"/>
                 <a:cs typeface="Arial"/>
               </a:rPr>
-              <a:t>IDEF0 TO BE: контекст управляемого процесса</a:t>
+              <a:t>IDEF0 TO BE: формирование карточек в ИС</a:t>
             </a:r>
           </a:p>
         </p:txBody>
       </p:sp>
       <p:pic>
         <p:nvPicPr>
-          <p:cNvPr id="4" name=""/>
+          <p:cNvPr id="2" name="">
+            <a:extLst xmlns:a="http://schemas.openxmlformats.org/drawingml/2006/main">
+              <a:ext uri="{FF2B5EF4-FFF2-40B4-BE49-F238E27FC236}">
+                <a16:creationId xmlns:a16="http://schemas.microsoft.com/office/drawing/2014/main" id="{ECF36527-0572-40C3-9690-9082EF77D999}"/>
+              </a:ext>
+            </a:extLst>
+          </p:cNvPr>
           <p:cNvPicPr>
             <a:picLocks xmlns:a="http://schemas.openxmlformats.org/drawingml/2006/main" noChangeAspect="1"/>
           </p:cNvPicPr>
           <p:nvPr/>
         </p:nvPicPr>
         <p:blipFill>
-          <a:blip xmlns:r="http://schemas.openxmlformats.org/officeDocument/2006/relationships" xmlns:a="http://schemas.openxmlformats.org/drawingml/2006/main" r:embed="R32741d406475434d"/>
+          <a:blip xmlns:r="http://schemas.openxmlformats.org/officeDocument/2006/relationships" xmlns:a="http://schemas.openxmlformats.org/drawingml/2006/main" r:embed="R935818ea935d40d1"/>
           <a:stretch xmlns:a="http://schemas.openxmlformats.org/drawingml/2006/main"/>
         </p:blipFill>
         <p:spPr>
@@ -3253,7 +5453,7 @@
     </p:spTree>
     <p:extLst>
       <p:ext uri="{BB962C8B-B14F-4D97-AF65-F5344CB8AC3E}">
-        <p14:creationId xmlns:p14="http://schemas.microsoft.com/office/powerpoint/2010/main" val="2023623535"/>
+        <p14:creationId xmlns:p14="http://schemas.microsoft.com/office/powerpoint/2010/main" val="457688255"/>
       </p:ext>
     </p:extLst>
   </p:cSld>
@@ -3284,7 +5484,7 @@
           <p:cNvPr id="3" name="">
             <a:extLst xmlns:a="http://schemas.openxmlformats.org/drawingml/2006/main">
               <a:ext uri="{FF2B5EF4-FFF2-40B4-BE49-F238E27FC236}">
-                <a16:creationId xmlns:a16="http://schemas.microsoft.com/office/drawing/2014/main" id="{5CFBC7C4-6DB7-4DFA-8AAA-1EFB075D4E26}"/>
+                <a16:creationId xmlns:a16="http://schemas.microsoft.com/office/drawing/2014/main" id="{042D313A-BAF7-40D7-BC86-7C737158B966}"/>
               </a:ext>
             </a:extLst>
           </p:cNvPr>
@@ -3310,7 +5510,18 @@
           <a:bodyPr xmlns:a="http://schemas.openxmlformats.org/drawingml/2006/main" anchor="ctr">
             <a:noAutofit/>
           </a:bodyPr>
-          <a:lstStyle xmlns:a="http://schemas.openxmlformats.org/drawingml/2006/main"/>
+          <a:lstStyle xmlns:a="http://schemas.openxmlformats.org/drawingml/2006/main">
+            <a:defPPr algn="l">
+              <a:defRPr sz="2700" b="1">
+                <a:solidFill>
+                  <a:srgbClr val="161616"/>
+                </a:solidFill>
+                <a:latin typeface="Arial"/>
+                <a:ea typeface="Arial"/>
+                <a:cs typeface="Arial"/>
+              </a:defRPr>
+            </a:defPPr>
+          </a:lstStyle>
           <a:p xmlns:a="http://schemas.openxmlformats.org/drawingml/2006/main">
             <a:pPr algn="l">
               <a:defRPr sz="2700" b="1">
@@ -3338,14 +5549,20 @@
       </p:sp>
       <p:pic>
         <p:nvPicPr>
-          <p:cNvPr id="4" name=""/>
+          <p:cNvPr id="2" name="">
+            <a:extLst xmlns:a="http://schemas.openxmlformats.org/drawingml/2006/main">
+              <a:ext uri="{FF2B5EF4-FFF2-40B4-BE49-F238E27FC236}">
+                <a16:creationId xmlns:a16="http://schemas.microsoft.com/office/drawing/2014/main" id="{6525252F-E79D-4214-A24D-A6FD3A5BD660}"/>
+              </a:ext>
+            </a:extLst>
+          </p:cNvPr>
           <p:cNvPicPr>
             <a:picLocks xmlns:a="http://schemas.openxmlformats.org/drawingml/2006/main" noChangeAspect="1"/>
           </p:cNvPicPr>
           <p:nvPr/>
         </p:nvPicPr>
         <p:blipFill>
-          <a:blip xmlns:r="http://schemas.openxmlformats.org/officeDocument/2006/relationships" xmlns:a="http://schemas.openxmlformats.org/drawingml/2006/main" r:embed="R365ea8ea9ae246b3"/>
+          <a:blip xmlns:r="http://schemas.openxmlformats.org/officeDocument/2006/relationships" xmlns:a="http://schemas.openxmlformats.org/drawingml/2006/main" r:embed="R8076fee7699344ea"/>
           <a:stretch xmlns:a="http://schemas.openxmlformats.org/drawingml/2006/main"/>
         </p:blipFill>
         <p:spPr>
@@ -3361,7 +5578,7 @@
     </p:spTree>
     <p:extLst>
       <p:ext uri="{BB962C8B-B14F-4D97-AF65-F5344CB8AC3E}">
-        <p14:creationId xmlns:p14="http://schemas.microsoft.com/office/powerpoint/2010/main" val="1889018658"/>
+        <p14:creationId xmlns:p14="http://schemas.microsoft.com/office/powerpoint/2010/main" val="1975313117"/>
       </p:ext>
     </p:extLst>
   </p:cSld>
@@ -3392,7 +5609,7 @@
           <p:cNvPr id="3" name="">
             <a:extLst xmlns:a="http://schemas.openxmlformats.org/drawingml/2006/main">
               <a:ext uri="{FF2B5EF4-FFF2-40B4-BE49-F238E27FC236}">
-                <a16:creationId xmlns:a16="http://schemas.microsoft.com/office/drawing/2014/main" id="{26F3777F-2EA4-470C-8878-750B749420D2}"/>
+                <a16:creationId xmlns:a16="http://schemas.microsoft.com/office/drawing/2014/main" id="{1DFBDE06-932A-435B-BA58-E329DE1C1B0A}"/>
               </a:ext>
             </a:extLst>
           </p:cNvPr>
@@ -3418,7 +5635,18 @@
           <a:bodyPr xmlns:a="http://schemas.openxmlformats.org/drawingml/2006/main" anchor="ctr">
             <a:noAutofit/>
           </a:bodyPr>
-          <a:lstStyle xmlns:a="http://schemas.openxmlformats.org/drawingml/2006/main"/>
+          <a:lstStyle xmlns:a="http://schemas.openxmlformats.org/drawingml/2006/main">
+            <a:defPPr algn="l">
+              <a:defRPr sz="2700" b="1">
+                <a:solidFill>
+                  <a:srgbClr val="161616"/>
+                </a:solidFill>
+                <a:latin typeface="Arial"/>
+                <a:ea typeface="Arial"/>
+                <a:cs typeface="Arial"/>
+              </a:defRPr>
+            </a:defPPr>
+          </a:lstStyle>
           <a:p xmlns:a="http://schemas.openxmlformats.org/drawingml/2006/main">
             <a:pPr algn="l">
               <a:defRPr sz="2700" b="1">
@@ -3446,20 +5674,26 @@
       </p:sp>
       <p:pic>
         <p:nvPicPr>
-          <p:cNvPr id="4" name=""/>
+          <p:cNvPr id="2" name="">
+            <a:extLst xmlns:a="http://schemas.openxmlformats.org/drawingml/2006/main">
+              <a:ext uri="{FF2B5EF4-FFF2-40B4-BE49-F238E27FC236}">
+                <a16:creationId xmlns:a16="http://schemas.microsoft.com/office/drawing/2014/main" id="{63FE6E9C-2292-4327-AD18-25DB75F86DC3}"/>
+              </a:ext>
+            </a:extLst>
+          </p:cNvPr>
           <p:cNvPicPr>
             <a:picLocks xmlns:a="http://schemas.openxmlformats.org/drawingml/2006/main" noChangeAspect="1"/>
           </p:cNvPicPr>
           <p:nvPr/>
         </p:nvPicPr>
         <p:blipFill>
-          <a:blip xmlns:r="http://schemas.openxmlformats.org/officeDocument/2006/relationships" xmlns:a="http://schemas.openxmlformats.org/drawingml/2006/main" r:embed="R86c8104ba3bb491c"/>
+          <a:blip xmlns:r="http://schemas.openxmlformats.org/officeDocument/2006/relationships" xmlns:a="http://schemas.openxmlformats.org/drawingml/2006/main" r:embed="R412b1d808da54c3c"/>
           <a:stretch xmlns:a="http://schemas.openxmlformats.org/drawingml/2006/main"/>
         </p:blipFill>
         <p:spPr>
           <a:xfrm xmlns:a="http://schemas.openxmlformats.org/drawingml/2006/main">
-            <a:off x="1453510" y="1285875"/>
-            <a:ext cx="9284980" cy="5000625"/>
+            <a:off x="571500" y="1961787"/>
+            <a:ext cx="11049000" cy="3648801"/>
           </a:xfrm>
           <a:prstGeom xmlns:a="http://schemas.openxmlformats.org/drawingml/2006/main" prst="rect">
             <a:avLst/>
@@ -3469,7 +5703,7 @@
     </p:spTree>
     <p:extLst>
       <p:ext uri="{BB962C8B-B14F-4D97-AF65-F5344CB8AC3E}">
-        <p14:creationId xmlns:p14="http://schemas.microsoft.com/office/powerpoint/2010/main" val="343065144"/>
+        <p14:creationId xmlns:p14="http://schemas.microsoft.com/office/powerpoint/2010/main" val="555816863"/>
       </p:ext>
     </p:extLst>
   </p:cSld>
@@ -3500,7 +5734,7 @@
           <p:cNvPr id="3" name="">
             <a:extLst xmlns:a="http://schemas.openxmlformats.org/drawingml/2006/main">
               <a:ext uri="{FF2B5EF4-FFF2-40B4-BE49-F238E27FC236}">
-                <a16:creationId xmlns:a16="http://schemas.microsoft.com/office/drawing/2014/main" id="{A08D5BE2-71F6-466D-8581-2D13858FC146}"/>
+                <a16:creationId xmlns:a16="http://schemas.microsoft.com/office/drawing/2014/main" id="{FBD6A069-9337-47EC-8718-90E0C4FD971F}"/>
               </a:ext>
             </a:extLst>
           </p:cNvPr>
@@ -3526,7 +5760,18 @@
           <a:bodyPr xmlns:a="http://schemas.openxmlformats.org/drawingml/2006/main" anchor="ctr">
             <a:noAutofit/>
           </a:bodyPr>
-          <a:lstStyle xmlns:a="http://schemas.openxmlformats.org/drawingml/2006/main"/>
+          <a:lstStyle xmlns:a="http://schemas.openxmlformats.org/drawingml/2006/main">
+            <a:defPPr algn="l">
+              <a:defRPr sz="2700" b="1">
+                <a:solidFill>
+                  <a:srgbClr val="161616"/>
+                </a:solidFill>
+                <a:latin typeface="Arial"/>
+                <a:ea typeface="Arial"/>
+                <a:cs typeface="Arial"/>
+              </a:defRPr>
+            </a:defPPr>
+          </a:lstStyle>
           <a:p xmlns:a="http://schemas.openxmlformats.org/drawingml/2006/main">
             <a:pPr algn="l">
               <a:defRPr sz="2700" b="1">
@@ -3554,20 +5799,26 @@
       </p:sp>
       <p:pic>
         <p:nvPicPr>
-          <p:cNvPr id="4" name=""/>
+          <p:cNvPr id="2" name="">
+            <a:extLst xmlns:a="http://schemas.openxmlformats.org/drawingml/2006/main">
+              <a:ext uri="{FF2B5EF4-FFF2-40B4-BE49-F238E27FC236}">
+                <a16:creationId xmlns:a16="http://schemas.microsoft.com/office/drawing/2014/main" id="{AE51BFF0-B633-4CB5-99F8-BFF33376C1FB}"/>
+              </a:ext>
+            </a:extLst>
+          </p:cNvPr>
           <p:cNvPicPr>
             <a:picLocks xmlns:a="http://schemas.openxmlformats.org/drawingml/2006/main" noChangeAspect="1"/>
           </p:cNvPicPr>
           <p:nvPr/>
         </p:nvPicPr>
         <p:blipFill>
-          <a:blip xmlns:r="http://schemas.openxmlformats.org/officeDocument/2006/relationships" xmlns:a="http://schemas.openxmlformats.org/drawingml/2006/main" r:embed="R539ec704c04d4123"/>
+          <a:blip xmlns:r="http://schemas.openxmlformats.org/officeDocument/2006/relationships" xmlns:a="http://schemas.openxmlformats.org/drawingml/2006/main" r:embed="R8613cc85ad084d51"/>
           <a:stretch xmlns:a="http://schemas.openxmlformats.org/drawingml/2006/main"/>
         </p:blipFill>
         <p:spPr>
           <a:xfrm xmlns:a="http://schemas.openxmlformats.org/drawingml/2006/main">
-            <a:off x="1606341" y="1285875"/>
-            <a:ext cx="8979318" cy="5000625"/>
+            <a:off x="571500" y="1946003"/>
+            <a:ext cx="11049000" cy="3680369"/>
           </a:xfrm>
           <a:prstGeom xmlns:a="http://schemas.openxmlformats.org/drawingml/2006/main" prst="rect">
             <a:avLst/>
@@ -3577,7 +5828,7 @@
     </p:spTree>
     <p:extLst>
       <p:ext uri="{BB962C8B-B14F-4D97-AF65-F5344CB8AC3E}">
-        <p14:creationId xmlns:p14="http://schemas.microsoft.com/office/powerpoint/2010/main" val="1469722470"/>
+        <p14:creationId xmlns:p14="http://schemas.microsoft.com/office/powerpoint/2010/main" val="323197071"/>
       </p:ext>
     </p:extLst>
   </p:cSld>
@@ -3608,7 +5859,7 @@
           <p:cNvPr id="3" name="">
             <a:extLst xmlns:a="http://schemas.openxmlformats.org/drawingml/2006/main">
               <a:ext uri="{FF2B5EF4-FFF2-40B4-BE49-F238E27FC236}">
-                <a16:creationId xmlns:a16="http://schemas.microsoft.com/office/drawing/2014/main" id="{39289CA5-D1E9-4D01-AA2D-26FFB369FB2D}"/>
+                <a16:creationId xmlns:a16="http://schemas.microsoft.com/office/drawing/2014/main" id="{4FB54FBC-47E0-415F-A8DA-6E3F61D2AA1F}"/>
               </a:ext>
             </a:extLst>
           </p:cNvPr>
@@ -3634,7 +5885,18 @@
           <a:bodyPr xmlns:a="http://schemas.openxmlformats.org/drawingml/2006/main" anchor="ctr">
             <a:noAutofit/>
           </a:bodyPr>
-          <a:lstStyle xmlns:a="http://schemas.openxmlformats.org/drawingml/2006/main"/>
+          <a:lstStyle xmlns:a="http://schemas.openxmlformats.org/drawingml/2006/main">
+            <a:defPPr algn="l">
+              <a:defRPr sz="2700" b="1">
+                <a:solidFill>
+                  <a:srgbClr val="161616"/>
+                </a:solidFill>
+                <a:latin typeface="Arial"/>
+                <a:ea typeface="Arial"/>
+                <a:cs typeface="Arial"/>
+              </a:defRPr>
+            </a:defPPr>
+          </a:lstStyle>
           <a:p xmlns:a="http://schemas.openxmlformats.org/drawingml/2006/main">
             <a:pPr algn="l">
               <a:defRPr sz="2700" b="1">
@@ -3662,20 +5924,26 @@
       </p:sp>
       <p:pic>
         <p:nvPicPr>
-          <p:cNvPr id="4" name=""/>
+          <p:cNvPr id="2" name="">
+            <a:extLst xmlns:a="http://schemas.openxmlformats.org/drawingml/2006/main">
+              <a:ext uri="{FF2B5EF4-FFF2-40B4-BE49-F238E27FC236}">
+                <a16:creationId xmlns:a16="http://schemas.microsoft.com/office/drawing/2014/main" id="{9A231744-3001-4599-B06E-5254789DE166}"/>
+              </a:ext>
+            </a:extLst>
+          </p:cNvPr>
           <p:cNvPicPr>
             <a:picLocks xmlns:a="http://schemas.openxmlformats.org/drawingml/2006/main" noChangeAspect="1"/>
           </p:cNvPicPr>
           <p:nvPr/>
         </p:nvPicPr>
         <p:blipFill>
-          <a:blip xmlns:r="http://schemas.openxmlformats.org/officeDocument/2006/relationships" xmlns:a="http://schemas.openxmlformats.org/drawingml/2006/main" r:embed="R34f670d516374e9b"/>
+          <a:blip xmlns:r="http://schemas.openxmlformats.org/officeDocument/2006/relationships" xmlns:a="http://schemas.openxmlformats.org/drawingml/2006/main" r:embed="Re5175685c09f4382"/>
           <a:stretch xmlns:a="http://schemas.openxmlformats.org/drawingml/2006/main"/>
         </p:blipFill>
         <p:spPr>
           <a:xfrm xmlns:a="http://schemas.openxmlformats.org/drawingml/2006/main">
-            <a:off x="571500" y="1534296"/>
-            <a:ext cx="11049000" cy="4503783"/>
+            <a:off x="571500" y="2144622"/>
+            <a:ext cx="11049000" cy="3283131"/>
           </a:xfrm>
           <a:prstGeom xmlns:a="http://schemas.openxmlformats.org/drawingml/2006/main" prst="rect">
             <a:avLst/>
@@ -3685,7 +5953,7 @@
     </p:spTree>
     <p:extLst>
       <p:ext uri="{BB962C8B-B14F-4D97-AF65-F5344CB8AC3E}">
-        <p14:creationId xmlns:p14="http://schemas.microsoft.com/office/powerpoint/2010/main" val="670667975"/>
+        <p14:creationId xmlns:p14="http://schemas.microsoft.com/office/powerpoint/2010/main" val="289041734"/>
       </p:ext>
     </p:extLst>
   </p:cSld>
@@ -3716,7 +5984,7 @@
           <p:cNvPr id="3" name="">
             <a:extLst xmlns:a="http://schemas.openxmlformats.org/drawingml/2006/main">
               <a:ext uri="{FF2B5EF4-FFF2-40B4-BE49-F238E27FC236}">
-                <a16:creationId xmlns:a16="http://schemas.microsoft.com/office/drawing/2014/main" id="{8B1ED0BF-6EFD-424F-87EE-FC048374B8C9}"/>
+                <a16:creationId xmlns:a16="http://schemas.microsoft.com/office/drawing/2014/main" id="{697BDB78-3E24-4A88-8F75-51E5A1F1E2E5}"/>
               </a:ext>
             </a:extLst>
           </p:cNvPr>
@@ -3742,7 +6010,18 @@
           <a:bodyPr xmlns:a="http://schemas.openxmlformats.org/drawingml/2006/main" anchor="ctr">
             <a:noAutofit/>
           </a:bodyPr>
-          <a:lstStyle xmlns:a="http://schemas.openxmlformats.org/drawingml/2006/main"/>
+          <a:lstStyle xmlns:a="http://schemas.openxmlformats.org/drawingml/2006/main">
+            <a:defPPr algn="l">
+              <a:defRPr sz="2700" b="1">
+                <a:solidFill>
+                  <a:srgbClr val="161616"/>
+                </a:solidFill>
+                <a:latin typeface="Arial"/>
+                <a:ea typeface="Arial"/>
+                <a:cs typeface="Arial"/>
+              </a:defRPr>
+            </a:defPPr>
+          </a:lstStyle>
           <a:p xmlns:a="http://schemas.openxmlformats.org/drawingml/2006/main">
             <a:pPr algn="l">
               <a:defRPr sz="2700" b="1">
@@ -3770,14 +6049,20 @@
       </p:sp>
       <p:pic>
         <p:nvPicPr>
-          <p:cNvPr id="4" name=""/>
+          <p:cNvPr id="2" name="">
+            <a:extLst xmlns:a="http://schemas.openxmlformats.org/drawingml/2006/main">
+              <a:ext uri="{FF2B5EF4-FFF2-40B4-BE49-F238E27FC236}">
+                <a16:creationId xmlns:a16="http://schemas.microsoft.com/office/drawing/2014/main" id="{D702327E-8159-4BDE-B735-7E0B1712542E}"/>
+              </a:ext>
+            </a:extLst>
+          </p:cNvPr>
           <p:cNvPicPr>
             <a:picLocks xmlns:a="http://schemas.openxmlformats.org/drawingml/2006/main" noChangeAspect="1"/>
           </p:cNvPicPr>
           <p:nvPr/>
         </p:nvPicPr>
         <p:blipFill>
-          <a:blip xmlns:r="http://schemas.openxmlformats.org/officeDocument/2006/relationships" xmlns:a="http://schemas.openxmlformats.org/drawingml/2006/main" r:embed="R0a8be8497578412c"/>
+          <a:blip xmlns:r="http://schemas.openxmlformats.org/officeDocument/2006/relationships" xmlns:a="http://schemas.openxmlformats.org/drawingml/2006/main" r:embed="Rc18ef497a3ea42ff"/>
           <a:stretch xmlns:a="http://schemas.openxmlformats.org/drawingml/2006/main"/>
         </p:blipFill>
         <p:spPr>
@@ -3793,7 +6078,7 @@
     </p:spTree>
     <p:extLst>
       <p:ext uri="{BB962C8B-B14F-4D97-AF65-F5344CB8AC3E}">
-        <p14:creationId xmlns:p14="http://schemas.microsoft.com/office/powerpoint/2010/main" val="354635978"/>
+        <p14:creationId xmlns:p14="http://schemas.microsoft.com/office/powerpoint/2010/main" val="1819089371"/>
       </p:ext>
     </p:extLst>
   </p:cSld>
@@ -3824,7 +6109,7 @@
           <p:cNvPr id="3" name="">
             <a:extLst xmlns:a="http://schemas.openxmlformats.org/drawingml/2006/main">
               <a:ext uri="{FF2B5EF4-FFF2-40B4-BE49-F238E27FC236}">
-                <a16:creationId xmlns:a16="http://schemas.microsoft.com/office/drawing/2014/main" id="{CF51E322-468C-4081-9041-3E59DAB834C1}"/>
+                <a16:creationId xmlns:a16="http://schemas.microsoft.com/office/drawing/2014/main" id="{3E7CDA0E-EAA2-4D59-8B24-7972583BA394}"/>
               </a:ext>
             </a:extLst>
           </p:cNvPr>
@@ -3850,7 +6135,18 @@
           <a:bodyPr xmlns:a="http://schemas.openxmlformats.org/drawingml/2006/main" anchor="ctr">
             <a:noAutofit/>
           </a:bodyPr>
-          <a:lstStyle xmlns:a="http://schemas.openxmlformats.org/drawingml/2006/main"/>
+          <a:lstStyle xmlns:a="http://schemas.openxmlformats.org/drawingml/2006/main">
+            <a:defPPr algn="l">
+              <a:defRPr sz="2700" b="1">
+                <a:solidFill>
+                  <a:srgbClr val="161616"/>
+                </a:solidFill>
+                <a:latin typeface="Arial"/>
+                <a:ea typeface="Arial"/>
+                <a:cs typeface="Arial"/>
+              </a:defRPr>
+            </a:defPPr>
+          </a:lstStyle>
           <a:p xmlns:a="http://schemas.openxmlformats.org/drawingml/2006/main">
             <a:pPr algn="l">
               <a:defRPr sz="2700" b="1">
@@ -3878,20 +6174,26 @@
       </p:sp>
       <p:pic>
         <p:nvPicPr>
-          <p:cNvPr id="4" name=""/>
+          <p:cNvPr id="2" name="">
+            <a:extLst xmlns:a="http://schemas.openxmlformats.org/drawingml/2006/main">
+              <a:ext uri="{FF2B5EF4-FFF2-40B4-BE49-F238E27FC236}">
+                <a16:creationId xmlns:a16="http://schemas.microsoft.com/office/drawing/2014/main" id="{2299995E-5922-4FD7-8CBD-9E84CCD46397}"/>
+              </a:ext>
+            </a:extLst>
+          </p:cNvPr>
           <p:cNvPicPr>
             <a:picLocks xmlns:a="http://schemas.openxmlformats.org/drawingml/2006/main" noChangeAspect="1"/>
           </p:cNvPicPr>
           <p:nvPr/>
         </p:nvPicPr>
         <p:blipFill>
-          <a:blip xmlns:r="http://schemas.openxmlformats.org/officeDocument/2006/relationships" xmlns:a="http://schemas.openxmlformats.org/drawingml/2006/main" r:embed="R6bae3c4c86b84282"/>
+          <a:blip xmlns:r="http://schemas.openxmlformats.org/officeDocument/2006/relationships" xmlns:a="http://schemas.openxmlformats.org/drawingml/2006/main" r:embed="R8e2fe2c01158486b"/>
           <a:stretch xmlns:a="http://schemas.openxmlformats.org/drawingml/2006/main"/>
         </p:blipFill>
         <p:spPr>
           <a:xfrm xmlns:a="http://schemas.openxmlformats.org/drawingml/2006/main">
-            <a:off x="2319908" y="1285875"/>
-            <a:ext cx="7552184" cy="5000625"/>
+            <a:off x="3214981" y="1285875"/>
+            <a:ext cx="5762037" cy="5000625"/>
           </a:xfrm>
           <a:prstGeom xmlns:a="http://schemas.openxmlformats.org/drawingml/2006/main" prst="rect">
             <a:avLst/>
@@ -3901,7 +6203,7 @@
     </p:spTree>
     <p:extLst>
       <p:ext uri="{BB962C8B-B14F-4D97-AF65-F5344CB8AC3E}">
-        <p14:creationId xmlns:p14="http://schemas.microsoft.com/office/powerpoint/2010/main" val="1316292344"/>
+        <p14:creationId xmlns:p14="http://schemas.microsoft.com/office/powerpoint/2010/main" val="370177494"/>
       </p:ext>
     </p:extLst>
   </p:cSld>
@@ -3949,16 +6251,16 @@
         <a:srgbClr val="96607D"/>
       </a:folHlink>
     </a:clrScheme>
-    <a:fontScheme name="Office">
+    <a:fontScheme name="">
       <a:majorFont>
-        <a:latin typeface="Calibri Light"/>
-        <a:ea typeface="Calibri Light"/>
-        <a:cs typeface="Calibri Light"/>
+        <a:latin typeface="Aptos"/>
+        <a:ea typeface=""/>
+        <a:cs typeface=""/>
       </a:majorFont>
       <a:minorFont>
-        <a:latin typeface="Calibri"/>
-        <a:ea typeface="Calibri"/>
-        <a:cs typeface="Calibri"/>
+        <a:latin typeface="Aptos"/>
+        <a:ea typeface=""/>
+        <a:cs typeface=""/>
       </a:minorFont>
     </a:fontScheme>
     <a:fmtScheme name="ChatGPT">

</xml_diff>